<commit_message>
Redesign coaxial cable presentation: title slide, realistic illustrations
Co-Authored-By: Claude Opus 5.5 <noreply@anthropic.com>
Claude-Session: https://claude.ai/code/session_014t6tUZzpxufuWreCCCTSrh
</commit_message>
<xml_diff>
--- a/presentation/Толстый_коаксиальный_кабель.pptx
+++ b/presentation/Толстый_коаксиальный_кабель.pptx
@@ -3090,7 +3090,7 @@
     <p:bg>
       <p:bgPr>
         <a:solidFill>
-          <a:srgbClr val="141E30"/>
+          <a:srgbClr val="F8F9FC"/>
         </a:solidFill>
         <a:effectLst/>
       </p:bgPr>
@@ -3104,14 +3104,102 @@
       <p:grpSpPr/>
       <p:sp>
         <p:nvSpPr>
-          <p:cNvPr id="2" name="TextBox 1"/>
+          <p:cNvPr id="2" name="Rectangle 1"/>
+          <p:cNvSpPr/>
+          <p:nvPr/>
+        </p:nvSpPr>
+        <p:spPr>
+          <a:xfrm>
+            <a:off x="0" y="0"/>
+            <a:ext cx="12191695" cy="6858000"/>
+          </a:xfrm>
+          <a:prstGeom prst="rect">
+            <a:avLst/>
+          </a:prstGeom>
+          <a:solidFill>
+            <a:srgbClr val="14213D"/>
+          </a:solidFill>
+          <a:ln>
+            <a:noFill/>
+          </a:ln>
+          <a:effectLst/>
+        </p:spPr>
+        <p:style>
+          <a:lnRef idx="1">
+            <a:schemeClr val="accent1"/>
+          </a:lnRef>
+          <a:fillRef idx="3">
+            <a:schemeClr val="accent1"/>
+          </a:fillRef>
+          <a:effectRef idx="2">
+            <a:schemeClr val="accent1"/>
+          </a:effectRef>
+          <a:fontRef idx="minor">
+            <a:schemeClr val="lt1"/>
+          </a:fontRef>
+        </p:style>
+        <p:txBody>
+          <a:bodyPr rtlCol="0" anchor="ctr"/>
+          <a:lstStyle/>
+          <a:p>
+            <a:pPr algn="ctr"/>
+          </a:p>
+        </p:txBody>
+      </p:sp>
+      <p:sp>
+        <p:nvSpPr>
+          <p:cNvPr id="3" name="Rectangle 2"/>
+          <p:cNvSpPr/>
+          <p:nvPr/>
+        </p:nvSpPr>
+        <p:spPr>
+          <a:xfrm>
+            <a:off x="0" y="4343400"/>
+            <a:ext cx="12191695" cy="73152"/>
+          </a:xfrm>
+          <a:prstGeom prst="rect">
+            <a:avLst/>
+          </a:prstGeom>
+          <a:solidFill>
+            <a:srgbClr val="E8BC1C"/>
+          </a:solidFill>
+          <a:ln>
+            <a:noFill/>
+          </a:ln>
+          <a:effectLst/>
+        </p:spPr>
+        <p:style>
+          <a:lnRef idx="1">
+            <a:schemeClr val="accent1"/>
+          </a:lnRef>
+          <a:fillRef idx="3">
+            <a:schemeClr val="accent1"/>
+          </a:fillRef>
+          <a:effectRef idx="2">
+            <a:schemeClr val="accent1"/>
+          </a:effectRef>
+          <a:fontRef idx="minor">
+            <a:schemeClr val="lt1"/>
+          </a:fontRef>
+        </p:style>
+        <p:txBody>
+          <a:bodyPr rtlCol="0" anchor="ctr"/>
+          <a:lstStyle/>
+          <a:p>
+            <a:pPr algn="ctr"/>
+          </a:p>
+        </p:txBody>
+      </p:sp>
+      <p:sp>
+        <p:nvSpPr>
+          <p:cNvPr id="4" name="TextBox 3"/>
           <p:cNvSpPr txBox="1"/>
           <p:nvPr/>
         </p:nvSpPr>
         <p:spPr>
           <a:xfrm>
-            <a:off x="731520" y="1463040"/>
-            <a:ext cx="10698480" cy="1828800"/>
+            <a:off x="731520" y="457200"/>
+            <a:ext cx="10698480" cy="457200"/>
           </a:xfrm>
           <a:prstGeom prst="rect">
             <a:avLst/>
@@ -3124,32 +3212,33 @@
           </a:bodyPr>
           <a:lstStyle/>
           <a:p>
-            <a:pPr>
+            <a:pPr algn="ctr">
               <a:spcAft>
-                <a:spcPts val="1000"/>
+                <a:spcPts val="800"/>
               </a:spcAft>
-              <a:defRPr sz="5000" b="1">
-                <a:solidFill>
-                  <a:srgbClr val="F2C200"/>
-                </a:solidFill>
+              <a:defRPr sz="2000" b="1">
+                <a:solidFill>
+                  <a:srgbClr val="E8BC1C"/>
+                </a:solidFill>
+                <a:latin typeface="Calibri"/>
               </a:defRPr>
             </a:pPr>
             <a:r>
-              <a:t>Толстый коаксиальный кабель</a:t>
-            </a:r>
-          </a:p>
-        </p:txBody>
-      </p:sp>
-      <p:sp>
-        <p:nvSpPr>
-          <p:cNvPr id="3" name="TextBox 2"/>
+              <a:t>Дисциплина: Компьютерные сети</a:t>
+            </a:r>
+          </a:p>
+        </p:txBody>
+      </p:sp>
+      <p:sp>
+        <p:nvSpPr>
+          <p:cNvPr id="5" name="TextBox 4"/>
           <p:cNvSpPr txBox="1"/>
           <p:nvPr/>
         </p:nvSpPr>
         <p:spPr>
           <a:xfrm>
-            <a:off x="731520" y="2743200"/>
-            <a:ext cx="10698480" cy="914400"/>
+            <a:off x="731520" y="1005840"/>
+            <a:ext cx="10698480" cy="1097280"/>
           </a:xfrm>
           <a:prstGeom prst="rect">
             <a:avLst/>
@@ -3162,32 +3251,33 @@
           </a:bodyPr>
           <a:lstStyle/>
           <a:p>
-            <a:pPr>
+            <a:pPr algn="ctr">
               <a:spcAft>
-                <a:spcPts val="1000"/>
+                <a:spcPts val="800"/>
               </a:spcAft>
-              <a:defRPr sz="2800" b="0">
+              <a:defRPr sz="4600" b="1">
                 <a:solidFill>
                   <a:srgbClr val="FFFFFF"/>
                 </a:solidFill>
+                <a:latin typeface="Calibri"/>
               </a:defRPr>
             </a:pPr>
             <a:r>
-              <a:t>Thick Ethernet (10BASE5, RG-8)</a:t>
-            </a:r>
-          </a:p>
-        </p:txBody>
-      </p:sp>
-      <p:sp>
-        <p:nvSpPr>
-          <p:cNvPr id="4" name="TextBox 3"/>
+              <a:t>ТОЛСТЫЙ КОАКСИАЛЬНЫЙ КАБЕЛЬ</a:t>
+            </a:r>
+          </a:p>
+        </p:txBody>
+      </p:sp>
+      <p:sp>
+        <p:nvSpPr>
+          <p:cNvPr id="6" name="TextBox 5"/>
           <p:cNvSpPr txBox="1"/>
           <p:nvPr/>
         </p:nvSpPr>
         <p:spPr>
           <a:xfrm>
-            <a:off x="731520" y="4389120"/>
-            <a:ext cx="10698480" cy="1828800"/>
+            <a:off x="731520" y="1920240"/>
+            <a:ext cx="10698480" cy="548640"/>
           </a:xfrm>
           <a:prstGeom prst="rect">
             <a:avLst/>
@@ -3200,55 +3290,26 @@
           </a:bodyPr>
           <a:lstStyle/>
           <a:p>
-            <a:pPr>
+            <a:pPr algn="ctr">
               <a:spcAft>
-                <a:spcPts val="1000"/>
+                <a:spcPts val="800"/>
               </a:spcAft>
               <a:defRPr sz="2200" b="0">
                 <a:solidFill>
-                  <a:srgbClr val="FFFFFF"/>
-                </a:solidFill>
+                  <a:srgbClr val="BEC8DC"/>
+                </a:solidFill>
+                <a:latin typeface="Calibri"/>
               </a:defRPr>
             </a:pPr>
             <a:r>
-              <a:t>Выполнил: Воцуев Салах</a:t>
-            </a:r>
-          </a:p>
-          <a:p>
-            <a:pPr>
-              <a:spcAft>
-                <a:spcPts val="1000"/>
-              </a:spcAft>
-              <a:defRPr sz="2200" b="0">
-                <a:solidFill>
-                  <a:srgbClr val="FFFFFF"/>
-                </a:solidFill>
-              </a:defRPr>
-            </a:pPr>
-            <a:r>
-              <a:t>Группа: 2П1</a:t>
-            </a:r>
-          </a:p>
-          <a:p>
-            <a:pPr>
-              <a:spcAft>
-                <a:spcPts val="1000"/>
-              </a:spcAft>
-              <a:defRPr sz="2200" b="0">
-                <a:solidFill>
-                  <a:srgbClr val="FFFFFF"/>
-                </a:solidFill>
-              </a:defRPr>
-            </a:pPr>
-            <a:r>
-              <a:t>Дисциплина: Компьютерные сети</a:t>
+              <a:t>Thick Ethernet · 10BASE5 · RG-8</a:t>
             </a:r>
           </a:p>
         </p:txBody>
       </p:sp>
       <p:pic>
         <p:nvPicPr>
-          <p:cNvPr id="5" name="Picture 4" descr="img_section.png"/>
+          <p:cNvPr id="7" name="Picture 6" descr="img_cable_t.png"/>
           <p:cNvPicPr>
             <a:picLocks noChangeAspect="1"/>
           </p:cNvPicPr>
@@ -3262,14 +3323,170 @@
         </p:blipFill>
         <p:spPr>
           <a:xfrm>
-            <a:off x="8961120" y="3291840"/>
-            <a:ext cx="2743200" cy="2743200"/>
+            <a:off x="3108960" y="2697480"/>
+            <a:ext cx="5943600" cy="1058049"/>
           </a:xfrm>
           <a:prstGeom prst="rect">
             <a:avLst/>
           </a:prstGeom>
         </p:spPr>
       </p:pic>
+      <p:sp>
+        <p:nvSpPr>
+          <p:cNvPr id="8" name="Rounded Rectangle 7"/>
+          <p:cNvSpPr/>
+          <p:nvPr/>
+        </p:nvSpPr>
+        <p:spPr>
+          <a:xfrm>
+            <a:off x="3566160" y="4663440"/>
+            <a:ext cx="5029200" cy="1600200"/>
+          </a:xfrm>
+          <a:prstGeom prst="roundRect">
+            <a:avLst>
+              <a:gd name="adj" fmla="val 8000"/>
+            </a:avLst>
+          </a:prstGeom>
+          <a:solidFill>
+            <a:srgbClr val="FFFFFF"/>
+          </a:solidFill>
+          <a:ln>
+            <a:noFill/>
+          </a:ln>
+          <a:effectLst/>
+        </p:spPr>
+        <p:style>
+          <a:lnRef idx="1">
+            <a:schemeClr val="accent1"/>
+          </a:lnRef>
+          <a:fillRef idx="3">
+            <a:schemeClr val="accent1"/>
+          </a:fillRef>
+          <a:effectRef idx="2">
+            <a:schemeClr val="accent1"/>
+          </a:effectRef>
+          <a:fontRef idx="minor">
+            <a:schemeClr val="lt1"/>
+          </a:fontRef>
+        </p:style>
+        <p:txBody>
+          <a:bodyPr rtlCol="0" anchor="ctr"/>
+          <a:lstStyle/>
+          <a:p>
+            <a:pPr algn="ctr"/>
+          </a:p>
+        </p:txBody>
+      </p:sp>
+      <p:sp>
+        <p:nvSpPr>
+          <p:cNvPr id="9" name="TextBox 8"/>
+          <p:cNvSpPr txBox="1"/>
+          <p:nvPr/>
+        </p:nvSpPr>
+        <p:spPr>
+          <a:xfrm>
+            <a:off x="3566160" y="4754880"/>
+            <a:ext cx="5029200" cy="1463040"/>
+          </a:xfrm>
+          <a:prstGeom prst="rect">
+            <a:avLst/>
+          </a:prstGeom>
+          <a:noFill/>
+        </p:spPr>
+        <p:txBody>
+          <a:bodyPr wrap="square">
+            <a:spAutoFit/>
+          </a:bodyPr>
+          <a:lstStyle/>
+          <a:p>
+            <a:pPr algn="ctr">
+              <a:spcAft>
+                <a:spcPts val="600"/>
+              </a:spcAft>
+              <a:defRPr sz="2200" b="1">
+                <a:solidFill>
+                  <a:srgbClr val="14213D"/>
+                </a:solidFill>
+                <a:latin typeface="Calibri"/>
+              </a:defRPr>
+            </a:pPr>
+            <a:r>
+              <a:t>Выполнил: Воцуев Салах</a:t>
+            </a:r>
+          </a:p>
+          <a:p>
+            <a:pPr algn="ctr">
+              <a:spcAft>
+                <a:spcPts val="600"/>
+              </a:spcAft>
+              <a:defRPr sz="2200" b="0">
+                <a:solidFill>
+                  <a:srgbClr val="14213D"/>
+                </a:solidFill>
+                <a:latin typeface="Calibri"/>
+              </a:defRPr>
+            </a:pPr>
+            <a:r>
+              <a:t>Группа: 2П1</a:t>
+            </a:r>
+          </a:p>
+          <a:p>
+            <a:pPr algn="ctr">
+              <a:spcAft>
+                <a:spcPts val="600"/>
+              </a:spcAft>
+              <a:defRPr sz="2200" b="0">
+                <a:solidFill>
+                  <a:srgbClr val="14213D"/>
+                </a:solidFill>
+                <a:latin typeface="Calibri"/>
+              </a:defRPr>
+            </a:pPr>
+            <a:r>
+              <a:t>Дисциплина: Компьютерные сети</a:t>
+            </a:r>
+          </a:p>
+        </p:txBody>
+      </p:sp>
+      <p:sp>
+        <p:nvSpPr>
+          <p:cNvPr id="10" name="TextBox 9"/>
+          <p:cNvSpPr txBox="1"/>
+          <p:nvPr/>
+        </p:nvSpPr>
+        <p:spPr>
+          <a:xfrm>
+            <a:off x="731520" y="6400800"/>
+            <a:ext cx="10698480" cy="365760"/>
+          </a:xfrm>
+          <a:prstGeom prst="rect">
+            <a:avLst/>
+          </a:prstGeom>
+          <a:noFill/>
+        </p:spPr>
+        <p:txBody>
+          <a:bodyPr wrap="square">
+            <a:spAutoFit/>
+          </a:bodyPr>
+          <a:lstStyle/>
+          <a:p>
+            <a:pPr algn="ctr">
+              <a:spcAft>
+                <a:spcPts val="800"/>
+              </a:spcAft>
+              <a:defRPr sz="1400" b="0">
+                <a:solidFill>
+                  <a:srgbClr val="BEC8DC"/>
+                </a:solidFill>
+                <a:latin typeface="Calibri"/>
+              </a:defRPr>
+            </a:pPr>
+            <a:r>
+              <a:t>2026</a:t>
+            </a:r>
+          </a:p>
+        </p:txBody>
+      </p:sp>
     </p:spTree>
   </p:cSld>
   <p:clrMapOvr>
@@ -3284,7 +3501,7 @@
     <p:bg>
       <p:bgPr>
         <a:solidFill>
-          <a:srgbClr val="141E30"/>
+          <a:srgbClr val="F8F9FC"/>
         </a:solidFill>
         <a:effectLst/>
       </p:bgPr>
@@ -3298,14 +3515,102 @@
       <p:grpSpPr/>
       <p:sp>
         <p:nvSpPr>
-          <p:cNvPr id="2" name="TextBox 1"/>
+          <p:cNvPr id="2" name="Rectangle 1"/>
+          <p:cNvSpPr/>
+          <p:nvPr/>
+        </p:nvSpPr>
+        <p:spPr>
+          <a:xfrm>
+            <a:off x="0" y="0"/>
+            <a:ext cx="12191695" cy="1143000"/>
+          </a:xfrm>
+          <a:prstGeom prst="rect">
+            <a:avLst/>
+          </a:prstGeom>
+          <a:solidFill>
+            <a:srgbClr val="14213D"/>
+          </a:solidFill>
+          <a:ln>
+            <a:noFill/>
+          </a:ln>
+          <a:effectLst/>
+        </p:spPr>
+        <p:style>
+          <a:lnRef idx="1">
+            <a:schemeClr val="accent1"/>
+          </a:lnRef>
+          <a:fillRef idx="3">
+            <a:schemeClr val="accent1"/>
+          </a:fillRef>
+          <a:effectRef idx="2">
+            <a:schemeClr val="accent1"/>
+          </a:effectRef>
+          <a:fontRef idx="minor">
+            <a:schemeClr val="lt1"/>
+          </a:fontRef>
+        </p:style>
+        <p:txBody>
+          <a:bodyPr rtlCol="0" anchor="ctr"/>
+          <a:lstStyle/>
+          <a:p>
+            <a:pPr algn="ctr"/>
+          </a:p>
+        </p:txBody>
+      </p:sp>
+      <p:sp>
+        <p:nvSpPr>
+          <p:cNvPr id="3" name="Rectangle 2"/>
+          <p:cNvSpPr/>
+          <p:nvPr/>
+        </p:nvSpPr>
+        <p:spPr>
+          <a:xfrm>
+            <a:off x="0" y="1143000"/>
+            <a:ext cx="12191695" cy="73152"/>
+          </a:xfrm>
+          <a:prstGeom prst="rect">
+            <a:avLst/>
+          </a:prstGeom>
+          <a:solidFill>
+            <a:srgbClr val="E8BC1C"/>
+          </a:solidFill>
+          <a:ln>
+            <a:noFill/>
+          </a:ln>
+          <a:effectLst/>
+        </p:spPr>
+        <p:style>
+          <a:lnRef idx="1">
+            <a:schemeClr val="accent1"/>
+          </a:lnRef>
+          <a:fillRef idx="3">
+            <a:schemeClr val="accent1"/>
+          </a:fillRef>
+          <a:effectRef idx="2">
+            <a:schemeClr val="accent1"/>
+          </a:effectRef>
+          <a:fontRef idx="minor">
+            <a:schemeClr val="lt1"/>
+          </a:fontRef>
+        </p:style>
+        <p:txBody>
+          <a:bodyPr rtlCol="0" anchor="ctr"/>
+          <a:lstStyle/>
+          <a:p>
+            <a:pPr algn="ctr"/>
+          </a:p>
+        </p:txBody>
+      </p:sp>
+      <p:sp>
+        <p:nvSpPr>
+          <p:cNvPr id="4" name="TextBox 3"/>
           <p:cNvSpPr txBox="1"/>
           <p:nvPr/>
         </p:nvSpPr>
         <p:spPr>
           <a:xfrm>
-            <a:off x="548640" y="365760"/>
-            <a:ext cx="10972800" cy="914400"/>
+            <a:off x="548640" y="228600"/>
+            <a:ext cx="10972800" cy="822960"/>
           </a:xfrm>
           <a:prstGeom prst="rect">
             <a:avLst/>
@@ -3318,32 +3623,33 @@
           </a:bodyPr>
           <a:lstStyle/>
           <a:p>
-            <a:pPr>
+            <a:pPr algn="l">
               <a:spcAft>
-                <a:spcPts val="1000"/>
+                <a:spcPts val="800"/>
               </a:spcAft>
-              <a:defRPr sz="3600" b="1">
-                <a:solidFill>
-                  <a:srgbClr val="F2C200"/>
-                </a:solidFill>
+              <a:defRPr sz="3400" b="1">
+                <a:solidFill>
+                  <a:srgbClr val="FFFFFF"/>
+                </a:solidFill>
+                <a:latin typeface="Calibri"/>
               </a:defRPr>
             </a:pPr>
             <a:r>
-              <a:t>Что это такое</a:t>
-            </a:r>
-          </a:p>
-        </p:txBody>
-      </p:sp>
-      <p:sp>
-        <p:nvSpPr>
-          <p:cNvPr id="3" name="TextBox 2"/>
+              <a:t>Что такое толстый коаксиальный кабель</a:t>
+            </a:r>
+          </a:p>
+        </p:txBody>
+      </p:sp>
+      <p:sp>
+        <p:nvSpPr>
+          <p:cNvPr id="5" name="TextBox 4"/>
           <p:cNvSpPr txBox="1"/>
           <p:nvPr/>
         </p:nvSpPr>
         <p:spPr>
           <a:xfrm>
-            <a:off x="548640" y="1463040"/>
-            <a:ext cx="6492240" cy="5029200"/>
+            <a:off x="640080" y="1645920"/>
+            <a:ext cx="6309359" cy="4846320"/>
           </a:xfrm>
           <a:prstGeom prst="rect">
             <a:avLst/>
@@ -3356,55 +3662,90 @@
           </a:bodyPr>
           <a:lstStyle/>
           <a:p>
-            <a:pPr>
+            <a:pPr algn="l">
               <a:spcAft>
-                <a:spcPts val="1000"/>
+                <a:spcPts val="1200"/>
               </a:spcAft>
-              <a:defRPr sz="2200" b="0">
-                <a:solidFill>
-                  <a:srgbClr val="FFFFFF"/>
-                </a:solidFill>
+              <a:defRPr sz="2100" b="0">
+                <a:solidFill>
+                  <a:srgbClr val="14213D"/>
+                </a:solidFill>
+                <a:latin typeface="Calibri"/>
               </a:defRPr>
             </a:pPr>
             <a:r>
-              <a:t>• Толстый коаксиальный кабель (Thick Ethernet, «жёлтый кабель») — кабель для передачи электрических сигналов, у которого центральная жила и экран расположены на одной оси.</a:t>
-            </a:r>
-          </a:p>
-          <a:p>
-            <a:pPr>
+              <a:t>Толстый коаксиальный кабель («жёлтый кабель», Thick Ethernet) — кабель, в котором центральная жила и экран расположены на одной оси (co-axial — «соосный»).</a:t>
+            </a:r>
+          </a:p>
+          <a:p>
+            <a:pPr algn="l">
               <a:spcAft>
-                <a:spcPts val="1000"/>
+                <a:spcPts val="1200"/>
               </a:spcAft>
-              <a:defRPr sz="2200" b="0">
-                <a:solidFill>
-                  <a:srgbClr val="FFFFFF"/>
-                </a:solidFill>
+              <a:defRPr sz="2100" b="0">
+                <a:solidFill>
+                  <a:srgbClr val="14213D"/>
+                </a:solidFill>
+                <a:latin typeface="Calibri"/>
               </a:defRPr>
             </a:pPr>
             <a:r>
-              <a:t>• Диаметр около 10–12 мм, волновое сопротивление 50 Ом.</a:t>
-            </a:r>
-          </a:p>
-          <a:p>
-            <a:pPr>
+              <a:t>• Диаметр: около 10–12 мм</a:t>
+            </a:r>
+          </a:p>
+          <a:p>
+            <a:pPr algn="l">
               <a:spcAft>
-                <a:spcPts val="1000"/>
+                <a:spcPts val="1200"/>
               </a:spcAft>
-              <a:defRPr sz="2200" b="0">
-                <a:solidFill>
-                  <a:srgbClr val="FFFFFF"/>
-                </a:solidFill>
+              <a:defRPr sz="2100" b="0">
+                <a:solidFill>
+                  <a:srgbClr val="14213D"/>
+                </a:solidFill>
+                <a:latin typeface="Calibri"/>
               </a:defRPr>
             </a:pPr>
             <a:r>
-              <a:t>• Стандарт Ethernet 10BASE5 (IEEE 802.3), появился в начале 1980-х.</a:t>
+              <a:t>• Волновое сопротивление: 50 Ом</a:t>
+            </a:r>
+          </a:p>
+          <a:p>
+            <a:pPr algn="l">
+              <a:spcAft>
+                <a:spcPts val="1200"/>
+              </a:spcAft>
+              <a:defRPr sz="2100" b="0">
+                <a:solidFill>
+                  <a:srgbClr val="14213D"/>
+                </a:solidFill>
+                <a:latin typeface="Calibri"/>
+              </a:defRPr>
+            </a:pPr>
+            <a:r>
+              <a:t>• Стандарт: IEEE 802.3, 10BASE5</a:t>
+            </a:r>
+          </a:p>
+          <a:p>
+            <a:pPr algn="l">
+              <a:spcAft>
+                <a:spcPts val="1200"/>
+              </a:spcAft>
+              <a:defRPr sz="2100" b="0">
+                <a:solidFill>
+                  <a:srgbClr val="14213D"/>
+                </a:solidFill>
+                <a:latin typeface="Calibri"/>
+              </a:defRPr>
+            </a:pPr>
+            <a:r>
+              <a:t>• Появился в начале 1980-х годов</a:t>
             </a:r>
           </a:p>
         </p:txBody>
       </p:sp>
       <p:pic>
         <p:nvPicPr>
-          <p:cNvPr id="4" name="Picture 3" descr="img_section.png"/>
+          <p:cNvPr id="6" name="Picture 5" descr="img_section.png"/>
           <p:cNvPicPr>
             <a:picLocks noChangeAspect="1"/>
           </p:cNvPicPr>
@@ -3418,14 +3759,92 @@
         </p:blipFill>
         <p:spPr>
           <a:xfrm>
-            <a:off x="7619695" y="1645920"/>
-            <a:ext cx="4114800" cy="4114800"/>
+            <a:off x="7528255" y="1645920"/>
+            <a:ext cx="4206240" cy="4206240"/>
           </a:xfrm>
           <a:prstGeom prst="rect">
             <a:avLst/>
           </a:prstGeom>
         </p:spPr>
       </p:pic>
+      <p:sp>
+        <p:nvSpPr>
+          <p:cNvPr id="7" name="TextBox 6"/>
+          <p:cNvSpPr txBox="1"/>
+          <p:nvPr/>
+        </p:nvSpPr>
+        <p:spPr>
+          <a:xfrm>
+            <a:off x="11155680" y="6355080"/>
+            <a:ext cx="822960" cy="365760"/>
+          </a:xfrm>
+          <a:prstGeom prst="rect">
+            <a:avLst/>
+          </a:prstGeom>
+          <a:noFill/>
+        </p:spPr>
+        <p:txBody>
+          <a:bodyPr wrap="square">
+            <a:spAutoFit/>
+          </a:bodyPr>
+          <a:lstStyle/>
+          <a:p>
+            <a:pPr algn="r">
+              <a:spcAft>
+                <a:spcPts val="800"/>
+              </a:spcAft>
+              <a:defRPr sz="1400" b="0">
+                <a:solidFill>
+                  <a:srgbClr val="5A6478"/>
+                </a:solidFill>
+                <a:latin typeface="Calibri"/>
+              </a:defRPr>
+            </a:pPr>
+            <a:r>
+              <a:t>2</a:t>
+            </a:r>
+          </a:p>
+        </p:txBody>
+      </p:sp>
+      <p:sp>
+        <p:nvSpPr>
+          <p:cNvPr id="8" name="TextBox 7"/>
+          <p:cNvSpPr txBox="1"/>
+          <p:nvPr/>
+        </p:nvSpPr>
+        <p:spPr>
+          <a:xfrm>
+            <a:off x="548640" y="6355080"/>
+            <a:ext cx="7315200" cy="365760"/>
+          </a:xfrm>
+          <a:prstGeom prst="rect">
+            <a:avLst/>
+          </a:prstGeom>
+          <a:noFill/>
+        </p:spPr>
+        <p:txBody>
+          <a:bodyPr wrap="square">
+            <a:spAutoFit/>
+          </a:bodyPr>
+          <a:lstStyle/>
+          <a:p>
+            <a:pPr algn="l">
+              <a:spcAft>
+                <a:spcPts val="800"/>
+              </a:spcAft>
+              <a:defRPr sz="1200" b="0">
+                <a:solidFill>
+                  <a:srgbClr val="5A6478"/>
+                </a:solidFill>
+                <a:latin typeface="Calibri"/>
+              </a:defRPr>
+            </a:pPr>
+            <a:r>
+              <a:t>Воцуев Салах · гр. 2П1 · Компьютерные сети</a:t>
+            </a:r>
+          </a:p>
+        </p:txBody>
+      </p:sp>
     </p:spTree>
   </p:cSld>
   <p:clrMapOvr>
@@ -3440,7 +3859,7 @@
     <p:bg>
       <p:bgPr>
         <a:solidFill>
-          <a:srgbClr val="141E30"/>
+          <a:srgbClr val="F8F9FC"/>
         </a:solidFill>
         <a:effectLst/>
       </p:bgPr>
@@ -3454,14 +3873,102 @@
       <p:grpSpPr/>
       <p:sp>
         <p:nvSpPr>
-          <p:cNvPr id="2" name="TextBox 1"/>
+          <p:cNvPr id="2" name="Rectangle 1"/>
+          <p:cNvSpPr/>
+          <p:nvPr/>
+        </p:nvSpPr>
+        <p:spPr>
+          <a:xfrm>
+            <a:off x="0" y="0"/>
+            <a:ext cx="12191695" cy="1143000"/>
+          </a:xfrm>
+          <a:prstGeom prst="rect">
+            <a:avLst/>
+          </a:prstGeom>
+          <a:solidFill>
+            <a:srgbClr val="14213D"/>
+          </a:solidFill>
+          <a:ln>
+            <a:noFill/>
+          </a:ln>
+          <a:effectLst/>
+        </p:spPr>
+        <p:style>
+          <a:lnRef idx="1">
+            <a:schemeClr val="accent1"/>
+          </a:lnRef>
+          <a:fillRef idx="3">
+            <a:schemeClr val="accent1"/>
+          </a:fillRef>
+          <a:effectRef idx="2">
+            <a:schemeClr val="accent1"/>
+          </a:effectRef>
+          <a:fontRef idx="minor">
+            <a:schemeClr val="lt1"/>
+          </a:fontRef>
+        </p:style>
+        <p:txBody>
+          <a:bodyPr rtlCol="0" anchor="ctr"/>
+          <a:lstStyle/>
+          <a:p>
+            <a:pPr algn="ctr"/>
+          </a:p>
+        </p:txBody>
+      </p:sp>
+      <p:sp>
+        <p:nvSpPr>
+          <p:cNvPr id="3" name="Rectangle 2"/>
+          <p:cNvSpPr/>
+          <p:nvPr/>
+        </p:nvSpPr>
+        <p:spPr>
+          <a:xfrm>
+            <a:off x="0" y="1143000"/>
+            <a:ext cx="12191695" cy="73152"/>
+          </a:xfrm>
+          <a:prstGeom prst="rect">
+            <a:avLst/>
+          </a:prstGeom>
+          <a:solidFill>
+            <a:srgbClr val="E8BC1C"/>
+          </a:solidFill>
+          <a:ln>
+            <a:noFill/>
+          </a:ln>
+          <a:effectLst/>
+        </p:spPr>
+        <p:style>
+          <a:lnRef idx="1">
+            <a:schemeClr val="accent1"/>
+          </a:lnRef>
+          <a:fillRef idx="3">
+            <a:schemeClr val="accent1"/>
+          </a:fillRef>
+          <a:effectRef idx="2">
+            <a:schemeClr val="accent1"/>
+          </a:effectRef>
+          <a:fontRef idx="minor">
+            <a:schemeClr val="lt1"/>
+          </a:fontRef>
+        </p:style>
+        <p:txBody>
+          <a:bodyPr rtlCol="0" anchor="ctr"/>
+          <a:lstStyle/>
+          <a:p>
+            <a:pPr algn="ctr"/>
+          </a:p>
+        </p:txBody>
+      </p:sp>
+      <p:sp>
+        <p:nvSpPr>
+          <p:cNvPr id="4" name="TextBox 3"/>
           <p:cNvSpPr txBox="1"/>
           <p:nvPr/>
         </p:nvSpPr>
         <p:spPr>
           <a:xfrm>
-            <a:off x="548640" y="365760"/>
-            <a:ext cx="10972800" cy="914400"/>
+            <a:off x="548640" y="228600"/>
+            <a:ext cx="10972800" cy="822960"/>
           </a:xfrm>
           <a:prstGeom prst="rect">
             <a:avLst/>
@@ -3474,14 +3981,15 @@
           </a:bodyPr>
           <a:lstStyle/>
           <a:p>
-            <a:pPr>
+            <a:pPr algn="l">
               <a:spcAft>
-                <a:spcPts val="1000"/>
+                <a:spcPts val="800"/>
               </a:spcAft>
-              <a:defRPr sz="3600" b="1">
-                <a:solidFill>
-                  <a:srgbClr val="F2C200"/>
-                </a:solidFill>
+              <a:defRPr sz="3400" b="1">
+                <a:solidFill>
+                  <a:srgbClr val="FFFFFF"/>
+                </a:solidFill>
+                <a:latin typeface="Calibri"/>
               </a:defRPr>
             </a:pPr>
             <a:r>
@@ -3492,14 +4000,14 @@
       </p:sp>
       <p:sp>
         <p:nvSpPr>
-          <p:cNvPr id="3" name="TextBox 2"/>
+          <p:cNvPr id="5" name="TextBox 4"/>
           <p:cNvSpPr txBox="1"/>
           <p:nvPr/>
         </p:nvSpPr>
         <p:spPr>
           <a:xfrm>
-            <a:off x="548640" y="1463040"/>
-            <a:ext cx="4846320" cy="5029200"/>
+            <a:off x="640080" y="1645920"/>
+            <a:ext cx="3840479" cy="4846320"/>
           </a:xfrm>
           <a:prstGeom prst="rect">
             <a:avLst/>
@@ -3512,70 +4020,74 @@
           </a:bodyPr>
           <a:lstStyle/>
           <a:p>
-            <a:pPr>
+            <a:pPr algn="l">
               <a:spcAft>
-                <a:spcPts val="1000"/>
+                <a:spcPts val="1200"/>
               </a:spcAft>
-              <a:defRPr sz="2200" b="0">
-                <a:solidFill>
-                  <a:srgbClr val="FFFFFF"/>
-                </a:solidFill>
+              <a:defRPr sz="2100" b="0">
+                <a:solidFill>
+                  <a:srgbClr val="14213D"/>
+                </a:solidFill>
+                <a:latin typeface="Calibri"/>
               </a:defRPr>
             </a:pPr>
             <a:r>
-              <a:t>1. Центральная медная жила — передаёт сигнал.</a:t>
-            </a:r>
-          </a:p>
-          <a:p>
-            <a:pPr>
+              <a:t>1. Медная жила — передаёт сигнал</a:t>
+            </a:r>
+          </a:p>
+          <a:p>
+            <a:pPr algn="l">
               <a:spcAft>
-                <a:spcPts val="1000"/>
+                <a:spcPts val="1200"/>
               </a:spcAft>
-              <a:defRPr sz="2200" b="0">
-                <a:solidFill>
-                  <a:srgbClr val="FFFFFF"/>
-                </a:solidFill>
+              <a:defRPr sz="2100" b="0">
+                <a:solidFill>
+                  <a:srgbClr val="14213D"/>
+                </a:solidFill>
+                <a:latin typeface="Calibri"/>
               </a:defRPr>
             </a:pPr>
             <a:r>
-              <a:t>2. Диэлектрик — изолирует жилу от экрана.</a:t>
-            </a:r>
-          </a:p>
-          <a:p>
-            <a:pPr>
+              <a:t>2. Диэлектрик — изолирует жилу от экрана</a:t>
+            </a:r>
+          </a:p>
+          <a:p>
+            <a:pPr algn="l">
               <a:spcAft>
-                <a:spcPts val="1000"/>
+                <a:spcPts val="1200"/>
               </a:spcAft>
-              <a:defRPr sz="2200" b="0">
-                <a:solidFill>
-                  <a:srgbClr val="FFFFFF"/>
-                </a:solidFill>
+              <a:defRPr sz="2100" b="0">
+                <a:solidFill>
+                  <a:srgbClr val="14213D"/>
+                </a:solidFill>
+                <a:latin typeface="Calibri"/>
               </a:defRPr>
             </a:pPr>
             <a:r>
-              <a:t>3. Экран (фольга и оплётка) — защищает от помех.</a:t>
-            </a:r>
-          </a:p>
-          <a:p>
-            <a:pPr>
+              <a:t>3. Фольга и оплётка — экран от помех</a:t>
+            </a:r>
+          </a:p>
+          <a:p>
+            <a:pPr algn="l">
               <a:spcAft>
-                <a:spcPts val="1000"/>
+                <a:spcPts val="1200"/>
               </a:spcAft>
-              <a:defRPr sz="2200" b="0">
-                <a:solidFill>
-                  <a:srgbClr val="FFFFFF"/>
-                </a:solidFill>
+              <a:defRPr sz="2100" b="0">
+                <a:solidFill>
+                  <a:srgbClr val="14213D"/>
+                </a:solidFill>
+                <a:latin typeface="Calibri"/>
               </a:defRPr>
             </a:pPr>
             <a:r>
-              <a:t>4. Внешняя оболочка — защищает от повреждений.</a:t>
+              <a:t>4. Оболочка ПВХ — защита от повреждений</a:t>
             </a:r>
           </a:p>
         </p:txBody>
       </p:sp>
       <p:pic>
         <p:nvPicPr>
-          <p:cNvPr id="4" name="Picture 3" descr="img_layers.png"/>
+          <p:cNvPr id="6" name="Picture 5" descr="img_cable.png"/>
           <p:cNvPicPr>
             <a:picLocks noChangeAspect="1"/>
           </p:cNvPicPr>
@@ -3589,14 +4101,92 @@
         </p:blipFill>
         <p:spPr>
           <a:xfrm>
-            <a:off x="5973775" y="1645920"/>
-            <a:ext cx="5760720" cy="2400300"/>
+            <a:off x="5059375" y="2194560"/>
+            <a:ext cx="6675120" cy="2824089"/>
           </a:xfrm>
           <a:prstGeom prst="rect">
             <a:avLst/>
           </a:prstGeom>
         </p:spPr>
       </p:pic>
+      <p:sp>
+        <p:nvSpPr>
+          <p:cNvPr id="7" name="TextBox 6"/>
+          <p:cNvSpPr txBox="1"/>
+          <p:nvPr/>
+        </p:nvSpPr>
+        <p:spPr>
+          <a:xfrm>
+            <a:off x="11155680" y="6355080"/>
+            <a:ext cx="822960" cy="365760"/>
+          </a:xfrm>
+          <a:prstGeom prst="rect">
+            <a:avLst/>
+          </a:prstGeom>
+          <a:noFill/>
+        </p:spPr>
+        <p:txBody>
+          <a:bodyPr wrap="square">
+            <a:spAutoFit/>
+          </a:bodyPr>
+          <a:lstStyle/>
+          <a:p>
+            <a:pPr algn="r">
+              <a:spcAft>
+                <a:spcPts val="800"/>
+              </a:spcAft>
+              <a:defRPr sz="1400" b="0">
+                <a:solidFill>
+                  <a:srgbClr val="5A6478"/>
+                </a:solidFill>
+                <a:latin typeface="Calibri"/>
+              </a:defRPr>
+            </a:pPr>
+            <a:r>
+              <a:t>3</a:t>
+            </a:r>
+          </a:p>
+        </p:txBody>
+      </p:sp>
+      <p:sp>
+        <p:nvSpPr>
+          <p:cNvPr id="8" name="TextBox 7"/>
+          <p:cNvSpPr txBox="1"/>
+          <p:nvPr/>
+        </p:nvSpPr>
+        <p:spPr>
+          <a:xfrm>
+            <a:off x="548640" y="6355080"/>
+            <a:ext cx="7315200" cy="365760"/>
+          </a:xfrm>
+          <a:prstGeom prst="rect">
+            <a:avLst/>
+          </a:prstGeom>
+          <a:noFill/>
+        </p:spPr>
+        <p:txBody>
+          <a:bodyPr wrap="square">
+            <a:spAutoFit/>
+          </a:bodyPr>
+          <a:lstStyle/>
+          <a:p>
+            <a:pPr algn="l">
+              <a:spcAft>
+                <a:spcPts val="800"/>
+              </a:spcAft>
+              <a:defRPr sz="1200" b="0">
+                <a:solidFill>
+                  <a:srgbClr val="5A6478"/>
+                </a:solidFill>
+                <a:latin typeface="Calibri"/>
+              </a:defRPr>
+            </a:pPr>
+            <a:r>
+              <a:t>Воцуев Салах · гр. 2П1 · Компьютерные сети</a:t>
+            </a:r>
+          </a:p>
+        </p:txBody>
+      </p:sp>
     </p:spTree>
   </p:cSld>
   <p:clrMapOvr>
@@ -3611,7 +4201,7 @@
     <p:bg>
       <p:bgPr>
         <a:solidFill>
-          <a:srgbClr val="141E30"/>
+          <a:srgbClr val="F8F9FC"/>
         </a:solidFill>
         <a:effectLst/>
       </p:bgPr>
@@ -3625,14 +4215,102 @@
       <p:grpSpPr/>
       <p:sp>
         <p:nvSpPr>
-          <p:cNvPr id="2" name="TextBox 1"/>
+          <p:cNvPr id="2" name="Rectangle 1"/>
+          <p:cNvSpPr/>
+          <p:nvPr/>
+        </p:nvSpPr>
+        <p:spPr>
+          <a:xfrm>
+            <a:off x="0" y="0"/>
+            <a:ext cx="12191695" cy="1143000"/>
+          </a:xfrm>
+          <a:prstGeom prst="rect">
+            <a:avLst/>
+          </a:prstGeom>
+          <a:solidFill>
+            <a:srgbClr val="14213D"/>
+          </a:solidFill>
+          <a:ln>
+            <a:noFill/>
+          </a:ln>
+          <a:effectLst/>
+        </p:spPr>
+        <p:style>
+          <a:lnRef idx="1">
+            <a:schemeClr val="accent1"/>
+          </a:lnRef>
+          <a:fillRef idx="3">
+            <a:schemeClr val="accent1"/>
+          </a:fillRef>
+          <a:effectRef idx="2">
+            <a:schemeClr val="accent1"/>
+          </a:effectRef>
+          <a:fontRef idx="minor">
+            <a:schemeClr val="lt1"/>
+          </a:fontRef>
+        </p:style>
+        <p:txBody>
+          <a:bodyPr rtlCol="0" anchor="ctr"/>
+          <a:lstStyle/>
+          <a:p>
+            <a:pPr algn="ctr"/>
+          </a:p>
+        </p:txBody>
+      </p:sp>
+      <p:sp>
+        <p:nvSpPr>
+          <p:cNvPr id="3" name="Rectangle 2"/>
+          <p:cNvSpPr/>
+          <p:nvPr/>
+        </p:nvSpPr>
+        <p:spPr>
+          <a:xfrm>
+            <a:off x="0" y="1143000"/>
+            <a:ext cx="12191695" cy="73152"/>
+          </a:xfrm>
+          <a:prstGeom prst="rect">
+            <a:avLst/>
+          </a:prstGeom>
+          <a:solidFill>
+            <a:srgbClr val="E8BC1C"/>
+          </a:solidFill>
+          <a:ln>
+            <a:noFill/>
+          </a:ln>
+          <a:effectLst/>
+        </p:spPr>
+        <p:style>
+          <a:lnRef idx="1">
+            <a:schemeClr val="accent1"/>
+          </a:lnRef>
+          <a:fillRef idx="3">
+            <a:schemeClr val="accent1"/>
+          </a:fillRef>
+          <a:effectRef idx="2">
+            <a:schemeClr val="accent1"/>
+          </a:effectRef>
+          <a:fontRef idx="minor">
+            <a:schemeClr val="lt1"/>
+          </a:fontRef>
+        </p:style>
+        <p:txBody>
+          <a:bodyPr rtlCol="0" anchor="ctr"/>
+          <a:lstStyle/>
+          <a:p>
+            <a:pPr algn="ctr"/>
+          </a:p>
+        </p:txBody>
+      </p:sp>
+      <p:sp>
+        <p:nvSpPr>
+          <p:cNvPr id="4" name="TextBox 3"/>
           <p:cNvSpPr txBox="1"/>
           <p:nvPr/>
         </p:nvSpPr>
         <p:spPr>
           <a:xfrm>
-            <a:off x="548640" y="365760"/>
-            <a:ext cx="10972800" cy="914400"/>
+            <a:off x="548640" y="228600"/>
+            <a:ext cx="10972800" cy="822960"/>
           </a:xfrm>
           <a:prstGeom prst="rect">
             <a:avLst/>
@@ -3645,14 +4323,15 @@
           </a:bodyPr>
           <a:lstStyle/>
           <a:p>
-            <a:pPr>
+            <a:pPr algn="l">
               <a:spcAft>
-                <a:spcPts val="1000"/>
+                <a:spcPts val="800"/>
               </a:spcAft>
-              <a:defRPr sz="3600" b="1">
-                <a:solidFill>
-                  <a:srgbClr val="F2C200"/>
-                </a:solidFill>
+              <a:defRPr sz="3400" b="1">
+                <a:solidFill>
+                  <a:srgbClr val="FFFFFF"/>
+                </a:solidFill>
+                <a:latin typeface="Calibri"/>
               </a:defRPr>
             </a:pPr>
             <a:r>
@@ -3663,14 +4342,14 @@
       </p:sp>
       <p:sp>
         <p:nvSpPr>
-          <p:cNvPr id="3" name="TextBox 2"/>
+          <p:cNvPr id="5" name="TextBox 4"/>
           <p:cNvSpPr txBox="1"/>
           <p:nvPr/>
         </p:nvSpPr>
         <p:spPr>
           <a:xfrm>
-            <a:off x="548640" y="1463040"/>
-            <a:ext cx="10972800" cy="5029200"/>
+            <a:off x="640080" y="1645920"/>
+            <a:ext cx="6126479" cy="4846320"/>
           </a:xfrm>
           <a:prstGeom prst="rect">
             <a:avLst/>
@@ -3683,93 +4362,201 @@
           </a:bodyPr>
           <a:lstStyle/>
           <a:p>
-            <a:pPr>
+            <a:pPr algn="l">
               <a:spcAft>
-                <a:spcPts val="1000"/>
+                <a:spcPts val="1200"/>
               </a:spcAft>
-              <a:defRPr sz="2200" b="0">
-                <a:solidFill>
-                  <a:srgbClr val="FFFFFF"/>
-                </a:solidFill>
+              <a:defRPr sz="2100" b="0">
+                <a:solidFill>
+                  <a:srgbClr val="14213D"/>
+                </a:solidFill>
+                <a:latin typeface="Calibri"/>
               </a:defRPr>
             </a:pPr>
             <a:r>
-              <a:t>• Скорость передачи: 10 Мбит/с</a:t>
-            </a:r>
-          </a:p>
-          <a:p>
-            <a:pPr>
+              <a:t>• Скорость передачи — 10 Мбит/с</a:t>
+            </a:r>
+          </a:p>
+          <a:p>
+            <a:pPr algn="l">
               <a:spcAft>
-                <a:spcPts val="1000"/>
+                <a:spcPts val="1200"/>
               </a:spcAft>
-              <a:defRPr sz="2200" b="0">
-                <a:solidFill>
-                  <a:srgbClr val="FFFFFF"/>
-                </a:solidFill>
+              <a:defRPr sz="2100" b="0">
+                <a:solidFill>
+                  <a:srgbClr val="14213D"/>
+                </a:solidFill>
+                <a:latin typeface="Calibri"/>
               </a:defRPr>
             </a:pPr>
             <a:r>
-              <a:t>• Длина сегмента: до 500 м («5» в 10BASE5)</a:t>
-            </a:r>
-          </a:p>
-          <a:p>
-            <a:pPr>
+              <a:t>• Длина сегмента — до 500 м (цифра «5» в 10BASE5)</a:t>
+            </a:r>
+          </a:p>
+          <a:p>
+            <a:pPr algn="l">
               <a:spcAft>
-                <a:spcPts val="1000"/>
+                <a:spcPts val="1200"/>
               </a:spcAft>
-              <a:defRPr sz="2200" b="0">
-                <a:solidFill>
-                  <a:srgbClr val="FFFFFF"/>
-                </a:solidFill>
+              <a:defRPr sz="2100" b="0">
+                <a:solidFill>
+                  <a:srgbClr val="14213D"/>
+                </a:solidFill>
+                <a:latin typeface="Calibri"/>
               </a:defRPr>
             </a:pPr>
             <a:r>
-              <a:t>• До 100 устройств на сегмент</a:t>
-            </a:r>
-          </a:p>
-          <a:p>
-            <a:pPr>
+              <a:t>• До 100 устройств на один сегмент</a:t>
+            </a:r>
+          </a:p>
+          <a:p>
+            <a:pPr algn="l">
               <a:spcAft>
-                <a:spcPts val="1000"/>
+                <a:spcPts val="1200"/>
               </a:spcAft>
-              <a:defRPr sz="2200" b="0">
-                <a:solidFill>
-                  <a:srgbClr val="FFFFFF"/>
-                </a:solidFill>
+              <a:defRPr sz="2100" b="0">
+                <a:solidFill>
+                  <a:srgbClr val="14213D"/>
+                </a:solidFill>
+                <a:latin typeface="Calibri"/>
               </a:defRPr>
             </a:pPr>
             <a:r>
-              <a:t>• Минимальное расстояние между подключениями: 2,5 м</a:t>
-            </a:r>
-          </a:p>
-          <a:p>
-            <a:pPr>
+              <a:t>• Расстояние между подключениями — не менее 2,5 м</a:t>
+            </a:r>
+          </a:p>
+          <a:p>
+            <a:pPr algn="l">
               <a:spcAft>
-                <a:spcPts val="1000"/>
+                <a:spcPts val="1200"/>
               </a:spcAft>
-              <a:defRPr sz="2200" b="0">
-                <a:solidFill>
-                  <a:srgbClr val="FFFFFF"/>
-                </a:solidFill>
+              <a:defRPr sz="2100" b="0">
+                <a:solidFill>
+                  <a:srgbClr val="14213D"/>
+                </a:solidFill>
+                <a:latin typeface="Calibri"/>
               </a:defRPr>
             </a:pPr>
             <a:r>
-              <a:t>• Сопротивление: 50 Ом, на концах — терминаторы</a:t>
-            </a:r>
-          </a:p>
-          <a:p>
-            <a:pPr>
+              <a:t>• На концах кабеля — терминаторы 50 Ом</a:t>
+            </a:r>
+          </a:p>
+          <a:p>
+            <a:pPr algn="l">
               <a:spcAft>
-                <a:spcPts val="1000"/>
+                <a:spcPts val="1200"/>
               </a:spcAft>
-              <a:defRPr sz="2200" b="0">
-                <a:solidFill>
-                  <a:srgbClr val="FFFFFF"/>
-                </a:solidFill>
+              <a:defRPr sz="2100" b="0">
+                <a:solidFill>
+                  <a:srgbClr val="14213D"/>
+                </a:solidFill>
+                <a:latin typeface="Calibri"/>
               </a:defRPr>
             </a:pPr>
             <a:r>
-              <a:t>• Подключение через трансиверы («вампиры») и кабель AUI</a:t>
+              <a:t>• Подключение — через трансивер («вампир») и кабель AUI</a:t>
+            </a:r>
+          </a:p>
+        </p:txBody>
+      </p:sp>
+      <p:pic>
+        <p:nvPicPr>
+          <p:cNvPr id="6" name="Picture 5" descr="img_cable_nolabel.png"/>
+          <p:cNvPicPr>
+            <a:picLocks noChangeAspect="1"/>
+          </p:cNvPicPr>
+          <p:nvPr/>
+        </p:nvPicPr>
+        <p:blipFill>
+          <a:blip r:embed="rId2"/>
+          <a:stretch>
+            <a:fillRect/>
+          </a:stretch>
+        </p:blipFill>
+        <p:spPr>
+          <a:xfrm>
+            <a:off x="7345375" y="2926080"/>
+            <a:ext cx="4389120" cy="1856935"/>
+          </a:xfrm>
+          <a:prstGeom prst="rect">
+            <a:avLst/>
+          </a:prstGeom>
+        </p:spPr>
+      </p:pic>
+      <p:sp>
+        <p:nvSpPr>
+          <p:cNvPr id="7" name="TextBox 6"/>
+          <p:cNvSpPr txBox="1"/>
+          <p:nvPr/>
+        </p:nvSpPr>
+        <p:spPr>
+          <a:xfrm>
+            <a:off x="11155680" y="6355080"/>
+            <a:ext cx="822960" cy="365760"/>
+          </a:xfrm>
+          <a:prstGeom prst="rect">
+            <a:avLst/>
+          </a:prstGeom>
+          <a:noFill/>
+        </p:spPr>
+        <p:txBody>
+          <a:bodyPr wrap="square">
+            <a:spAutoFit/>
+          </a:bodyPr>
+          <a:lstStyle/>
+          <a:p>
+            <a:pPr algn="r">
+              <a:spcAft>
+                <a:spcPts val="800"/>
+              </a:spcAft>
+              <a:defRPr sz="1400" b="0">
+                <a:solidFill>
+                  <a:srgbClr val="5A6478"/>
+                </a:solidFill>
+                <a:latin typeface="Calibri"/>
+              </a:defRPr>
+            </a:pPr>
+            <a:r>
+              <a:t>4</a:t>
+            </a:r>
+          </a:p>
+        </p:txBody>
+      </p:sp>
+      <p:sp>
+        <p:nvSpPr>
+          <p:cNvPr id="8" name="TextBox 7"/>
+          <p:cNvSpPr txBox="1"/>
+          <p:nvPr/>
+        </p:nvSpPr>
+        <p:spPr>
+          <a:xfrm>
+            <a:off x="548640" y="6355080"/>
+            <a:ext cx="7315200" cy="365760"/>
+          </a:xfrm>
+          <a:prstGeom prst="rect">
+            <a:avLst/>
+          </a:prstGeom>
+          <a:noFill/>
+        </p:spPr>
+        <p:txBody>
+          <a:bodyPr wrap="square">
+            <a:spAutoFit/>
+          </a:bodyPr>
+          <a:lstStyle/>
+          <a:p>
+            <a:pPr algn="l">
+              <a:spcAft>
+                <a:spcPts val="800"/>
+              </a:spcAft>
+              <a:defRPr sz="1200" b="0">
+                <a:solidFill>
+                  <a:srgbClr val="5A6478"/>
+                </a:solidFill>
+                <a:latin typeface="Calibri"/>
+              </a:defRPr>
+            </a:pPr>
+            <a:r>
+              <a:t>Воцуев Салах · гр. 2П1 · Компьютерные сети</a:t>
             </a:r>
           </a:p>
         </p:txBody>
@@ -3788,7 +4575,7 @@
     <p:bg>
       <p:bgPr>
         <a:solidFill>
-          <a:srgbClr val="141E30"/>
+          <a:srgbClr val="F8F9FC"/>
         </a:solidFill>
         <a:effectLst/>
       </p:bgPr>
@@ -3802,14 +4589,102 @@
       <p:grpSpPr/>
       <p:sp>
         <p:nvSpPr>
-          <p:cNvPr id="2" name="TextBox 1"/>
+          <p:cNvPr id="2" name="Rectangle 1"/>
+          <p:cNvSpPr/>
+          <p:nvPr/>
+        </p:nvSpPr>
+        <p:spPr>
+          <a:xfrm>
+            <a:off x="0" y="0"/>
+            <a:ext cx="12191695" cy="1143000"/>
+          </a:xfrm>
+          <a:prstGeom prst="rect">
+            <a:avLst/>
+          </a:prstGeom>
+          <a:solidFill>
+            <a:srgbClr val="14213D"/>
+          </a:solidFill>
+          <a:ln>
+            <a:noFill/>
+          </a:ln>
+          <a:effectLst/>
+        </p:spPr>
+        <p:style>
+          <a:lnRef idx="1">
+            <a:schemeClr val="accent1"/>
+          </a:lnRef>
+          <a:fillRef idx="3">
+            <a:schemeClr val="accent1"/>
+          </a:fillRef>
+          <a:effectRef idx="2">
+            <a:schemeClr val="accent1"/>
+          </a:effectRef>
+          <a:fontRef idx="minor">
+            <a:schemeClr val="lt1"/>
+          </a:fontRef>
+        </p:style>
+        <p:txBody>
+          <a:bodyPr rtlCol="0" anchor="ctr"/>
+          <a:lstStyle/>
+          <a:p>
+            <a:pPr algn="ctr"/>
+          </a:p>
+        </p:txBody>
+      </p:sp>
+      <p:sp>
+        <p:nvSpPr>
+          <p:cNvPr id="3" name="Rectangle 2"/>
+          <p:cNvSpPr/>
+          <p:nvPr/>
+        </p:nvSpPr>
+        <p:spPr>
+          <a:xfrm>
+            <a:off x="0" y="1143000"/>
+            <a:ext cx="12191695" cy="73152"/>
+          </a:xfrm>
+          <a:prstGeom prst="rect">
+            <a:avLst/>
+          </a:prstGeom>
+          <a:solidFill>
+            <a:srgbClr val="E8BC1C"/>
+          </a:solidFill>
+          <a:ln>
+            <a:noFill/>
+          </a:ln>
+          <a:effectLst/>
+        </p:spPr>
+        <p:style>
+          <a:lnRef idx="1">
+            <a:schemeClr val="accent1"/>
+          </a:lnRef>
+          <a:fillRef idx="3">
+            <a:schemeClr val="accent1"/>
+          </a:fillRef>
+          <a:effectRef idx="2">
+            <a:schemeClr val="accent1"/>
+          </a:effectRef>
+          <a:fontRef idx="minor">
+            <a:schemeClr val="lt1"/>
+          </a:fontRef>
+        </p:style>
+        <p:txBody>
+          <a:bodyPr rtlCol="0" anchor="ctr"/>
+          <a:lstStyle/>
+          <a:p>
+            <a:pPr algn="ctr"/>
+          </a:p>
+        </p:txBody>
+      </p:sp>
+      <p:sp>
+        <p:nvSpPr>
+          <p:cNvPr id="4" name="TextBox 3"/>
           <p:cNvSpPr txBox="1"/>
           <p:nvPr/>
         </p:nvSpPr>
         <p:spPr>
           <a:xfrm>
-            <a:off x="548640" y="365760"/>
-            <a:ext cx="10972800" cy="914400"/>
+            <a:off x="548640" y="228600"/>
+            <a:ext cx="10972800" cy="822960"/>
           </a:xfrm>
           <a:prstGeom prst="rect">
             <a:avLst/>
@@ -3822,14 +4697,15 @@
           </a:bodyPr>
           <a:lstStyle/>
           <a:p>
-            <a:pPr>
+            <a:pPr algn="l">
               <a:spcAft>
-                <a:spcPts val="1000"/>
+                <a:spcPts val="800"/>
               </a:spcAft>
-              <a:defRPr sz="3600" b="1">
-                <a:solidFill>
-                  <a:srgbClr val="F2C200"/>
-                </a:solidFill>
+              <a:defRPr sz="3400" b="1">
+                <a:solidFill>
+                  <a:srgbClr val="FFFFFF"/>
+                </a:solidFill>
+                <a:latin typeface="Calibri"/>
               </a:defRPr>
             </a:pPr>
             <a:r>
@@ -3840,14 +4716,14 @@
       </p:sp>
       <p:sp>
         <p:nvSpPr>
-          <p:cNvPr id="3" name="TextBox 2"/>
+          <p:cNvPr id="5" name="TextBox 4"/>
           <p:cNvSpPr txBox="1"/>
           <p:nvPr/>
         </p:nvSpPr>
         <p:spPr>
           <a:xfrm>
-            <a:off x="548640" y="1463040"/>
-            <a:ext cx="4846320" cy="5029200"/>
+            <a:off x="640080" y="1645920"/>
+            <a:ext cx="4480559" cy="4846320"/>
           </a:xfrm>
           <a:prstGeom prst="rect">
             <a:avLst/>
@@ -3860,70 +4736,74 @@
           </a:bodyPr>
           <a:lstStyle/>
           <a:p>
-            <a:pPr>
+            <a:pPr algn="l">
               <a:spcAft>
-                <a:spcPts val="1000"/>
+                <a:spcPts val="1200"/>
               </a:spcAft>
-              <a:defRPr sz="2200" b="0">
-                <a:solidFill>
-                  <a:srgbClr val="FFFFFF"/>
-                </a:solidFill>
+              <a:defRPr sz="2100" b="0">
+                <a:solidFill>
+                  <a:srgbClr val="14213D"/>
+                </a:solidFill>
+                <a:latin typeface="Calibri"/>
               </a:defRPr>
             </a:pPr>
             <a:r>
-              <a:t>• Построение локальных сетей с топологией «общая шина».</a:t>
-            </a:r>
-          </a:p>
-          <a:p>
-            <a:pPr>
+              <a:t>• Локальные сети с топологией «общая шина»</a:t>
+            </a:r>
+          </a:p>
+          <a:p>
+            <a:pPr algn="l">
               <a:spcAft>
-                <a:spcPts val="1000"/>
+                <a:spcPts val="1200"/>
               </a:spcAft>
-              <a:defRPr sz="2200" b="0">
-                <a:solidFill>
-                  <a:srgbClr val="FFFFFF"/>
-                </a:solidFill>
+              <a:defRPr sz="2100" b="0">
+                <a:solidFill>
+                  <a:srgbClr val="14213D"/>
+                </a:solidFill>
+                <a:latin typeface="Calibri"/>
               </a:defRPr>
             </a:pPr>
             <a:r>
-              <a:t>• Магистраль (backbone), соединяющая сегменты сети в зданиях.</a:t>
-            </a:r>
-          </a:p>
-          <a:p>
-            <a:pPr>
+              <a:t>• Магистраль (backbone) между сегментами сети</a:t>
+            </a:r>
+          </a:p>
+          <a:p>
+            <a:pPr algn="l">
               <a:spcAft>
-                <a:spcPts val="1000"/>
+                <a:spcPts val="1200"/>
               </a:spcAft>
-              <a:defRPr sz="2200" b="0">
-                <a:solidFill>
-                  <a:srgbClr val="FFFFFF"/>
-                </a:solidFill>
+              <a:defRPr sz="2100" b="0">
+                <a:solidFill>
+                  <a:srgbClr val="14213D"/>
+                </a:solidFill>
+                <a:latin typeface="Calibri"/>
               </a:defRPr>
             </a:pPr>
             <a:r>
-              <a:t>• Сети с большими расстояниями и сильными помехами.</a:t>
-            </a:r>
-          </a:p>
-          <a:p>
-            <a:pPr>
+              <a:t>• Линии в местах с сильными помехами</a:t>
+            </a:r>
+          </a:p>
+          <a:p>
+            <a:pPr algn="l">
               <a:spcAft>
-                <a:spcPts val="1000"/>
+                <a:spcPts val="1200"/>
               </a:spcAft>
-              <a:defRPr sz="2200" b="0">
-                <a:solidFill>
-                  <a:srgbClr val="FFFFFF"/>
-                </a:solidFill>
+              <a:defRPr sz="2100" b="0">
+                <a:solidFill>
+                  <a:srgbClr val="14213D"/>
+                </a:solidFill>
+                <a:latin typeface="Calibri"/>
               </a:defRPr>
             </a:pPr>
             <a:r>
-              <a:t>• Сейчас — в основном в старых сетях; заменён витой парой и оптоволокном.</a:t>
+              <a:t>• Сегодня почти вытеснен витой парой и оптоволокном</a:t>
             </a:r>
           </a:p>
         </p:txBody>
       </p:sp>
       <p:pic>
         <p:nvPicPr>
-          <p:cNvPr id="4" name="Picture 3" descr="img_bus.png"/>
+          <p:cNvPr id="6" name="Picture 5" descr="img_bus.png"/>
           <p:cNvPicPr>
             <a:picLocks noChangeAspect="1"/>
           </p:cNvPicPr>
@@ -3937,14 +4817,92 @@
         </p:blipFill>
         <p:spPr>
           <a:xfrm>
-            <a:off x="5973775" y="1645920"/>
-            <a:ext cx="5760720" cy="2400300"/>
+            <a:off x="5699455" y="2103120"/>
+            <a:ext cx="6035040" cy="2553286"/>
           </a:xfrm>
           <a:prstGeom prst="rect">
             <a:avLst/>
           </a:prstGeom>
         </p:spPr>
       </p:pic>
+      <p:sp>
+        <p:nvSpPr>
+          <p:cNvPr id="7" name="TextBox 6"/>
+          <p:cNvSpPr txBox="1"/>
+          <p:nvPr/>
+        </p:nvSpPr>
+        <p:spPr>
+          <a:xfrm>
+            <a:off x="11155680" y="6355080"/>
+            <a:ext cx="822960" cy="365760"/>
+          </a:xfrm>
+          <a:prstGeom prst="rect">
+            <a:avLst/>
+          </a:prstGeom>
+          <a:noFill/>
+        </p:spPr>
+        <p:txBody>
+          <a:bodyPr wrap="square">
+            <a:spAutoFit/>
+          </a:bodyPr>
+          <a:lstStyle/>
+          <a:p>
+            <a:pPr algn="r">
+              <a:spcAft>
+                <a:spcPts val="800"/>
+              </a:spcAft>
+              <a:defRPr sz="1400" b="0">
+                <a:solidFill>
+                  <a:srgbClr val="5A6478"/>
+                </a:solidFill>
+                <a:latin typeface="Calibri"/>
+              </a:defRPr>
+            </a:pPr>
+            <a:r>
+              <a:t>5</a:t>
+            </a:r>
+          </a:p>
+        </p:txBody>
+      </p:sp>
+      <p:sp>
+        <p:nvSpPr>
+          <p:cNvPr id="8" name="TextBox 7"/>
+          <p:cNvSpPr txBox="1"/>
+          <p:nvPr/>
+        </p:nvSpPr>
+        <p:spPr>
+          <a:xfrm>
+            <a:off x="548640" y="6355080"/>
+            <a:ext cx="7315200" cy="365760"/>
+          </a:xfrm>
+          <a:prstGeom prst="rect">
+            <a:avLst/>
+          </a:prstGeom>
+          <a:noFill/>
+        </p:spPr>
+        <p:txBody>
+          <a:bodyPr wrap="square">
+            <a:spAutoFit/>
+          </a:bodyPr>
+          <a:lstStyle/>
+          <a:p>
+            <a:pPr algn="l">
+              <a:spcAft>
+                <a:spcPts val="800"/>
+              </a:spcAft>
+              <a:defRPr sz="1200" b="0">
+                <a:solidFill>
+                  <a:srgbClr val="5A6478"/>
+                </a:solidFill>
+                <a:latin typeface="Calibri"/>
+              </a:defRPr>
+            </a:pPr>
+            <a:r>
+              <a:t>Воцуев Салах · гр. 2П1 · Компьютерные сети</a:t>
+            </a:r>
+          </a:p>
+        </p:txBody>
+      </p:sp>
     </p:spTree>
   </p:cSld>
   <p:clrMapOvr>
@@ -3959,7 +4917,7 @@
     <p:bg>
       <p:bgPr>
         <a:solidFill>
-          <a:srgbClr val="141E30"/>
+          <a:srgbClr val="F8F9FC"/>
         </a:solidFill>
         <a:effectLst/>
       </p:bgPr>
@@ -3973,14 +4931,102 @@
       <p:grpSpPr/>
       <p:sp>
         <p:nvSpPr>
-          <p:cNvPr id="2" name="TextBox 1"/>
+          <p:cNvPr id="2" name="Rectangle 1"/>
+          <p:cNvSpPr/>
+          <p:nvPr/>
+        </p:nvSpPr>
+        <p:spPr>
+          <a:xfrm>
+            <a:off x="0" y="0"/>
+            <a:ext cx="12191695" cy="1143000"/>
+          </a:xfrm>
+          <a:prstGeom prst="rect">
+            <a:avLst/>
+          </a:prstGeom>
+          <a:solidFill>
+            <a:srgbClr val="14213D"/>
+          </a:solidFill>
+          <a:ln>
+            <a:noFill/>
+          </a:ln>
+          <a:effectLst/>
+        </p:spPr>
+        <p:style>
+          <a:lnRef idx="1">
+            <a:schemeClr val="accent1"/>
+          </a:lnRef>
+          <a:fillRef idx="3">
+            <a:schemeClr val="accent1"/>
+          </a:fillRef>
+          <a:effectRef idx="2">
+            <a:schemeClr val="accent1"/>
+          </a:effectRef>
+          <a:fontRef idx="minor">
+            <a:schemeClr val="lt1"/>
+          </a:fontRef>
+        </p:style>
+        <p:txBody>
+          <a:bodyPr rtlCol="0" anchor="ctr"/>
+          <a:lstStyle/>
+          <a:p>
+            <a:pPr algn="ctr"/>
+          </a:p>
+        </p:txBody>
+      </p:sp>
+      <p:sp>
+        <p:nvSpPr>
+          <p:cNvPr id="3" name="Rectangle 2"/>
+          <p:cNvSpPr/>
+          <p:nvPr/>
+        </p:nvSpPr>
+        <p:spPr>
+          <a:xfrm>
+            <a:off x="0" y="1143000"/>
+            <a:ext cx="12191695" cy="73152"/>
+          </a:xfrm>
+          <a:prstGeom prst="rect">
+            <a:avLst/>
+          </a:prstGeom>
+          <a:solidFill>
+            <a:srgbClr val="E8BC1C"/>
+          </a:solidFill>
+          <a:ln>
+            <a:noFill/>
+          </a:ln>
+          <a:effectLst/>
+        </p:spPr>
+        <p:style>
+          <a:lnRef idx="1">
+            <a:schemeClr val="accent1"/>
+          </a:lnRef>
+          <a:fillRef idx="3">
+            <a:schemeClr val="accent1"/>
+          </a:fillRef>
+          <a:effectRef idx="2">
+            <a:schemeClr val="accent1"/>
+          </a:effectRef>
+          <a:fontRef idx="minor">
+            <a:schemeClr val="lt1"/>
+          </a:fontRef>
+        </p:style>
+        <p:txBody>
+          <a:bodyPr rtlCol="0" anchor="ctr"/>
+          <a:lstStyle/>
+          <a:p>
+            <a:pPr algn="ctr"/>
+          </a:p>
+        </p:txBody>
+      </p:sp>
+      <p:sp>
+        <p:nvSpPr>
+          <p:cNvPr id="4" name="TextBox 3"/>
           <p:cNvSpPr txBox="1"/>
           <p:nvPr/>
         </p:nvSpPr>
         <p:spPr>
           <a:xfrm>
-            <a:off x="548640" y="365760"/>
-            <a:ext cx="10972800" cy="914400"/>
+            <a:off x="548640" y="228600"/>
+            <a:ext cx="10972800" cy="822960"/>
           </a:xfrm>
           <a:prstGeom prst="rect">
             <a:avLst/>
@@ -3993,14 +5039,15 @@
           </a:bodyPr>
           <a:lstStyle/>
           <a:p>
-            <a:pPr>
+            <a:pPr algn="l">
               <a:spcAft>
-                <a:spcPts val="1000"/>
+                <a:spcPts val="800"/>
               </a:spcAft>
-              <a:defRPr sz="3600" b="1">
-                <a:solidFill>
-                  <a:srgbClr val="F2C200"/>
-                </a:solidFill>
+              <a:defRPr sz="3400" b="1">
+                <a:solidFill>
+                  <a:srgbClr val="FFFFFF"/>
+                </a:solidFill>
+                <a:latin typeface="Calibri"/>
               </a:defRPr>
             </a:pPr>
             <a:r>
@@ -4011,14 +5058,14 @@
       </p:sp>
       <p:sp>
         <p:nvSpPr>
-          <p:cNvPr id="3" name="TextBox 2"/>
+          <p:cNvPr id="5" name="TextBox 4"/>
           <p:cNvSpPr txBox="1"/>
           <p:nvPr/>
         </p:nvSpPr>
         <p:spPr>
           <a:xfrm>
-            <a:off x="548640" y="1463040"/>
-            <a:ext cx="10972800" cy="5029200"/>
+            <a:off x="640080" y="1645920"/>
+            <a:ext cx="10972800" cy="4846320"/>
           </a:xfrm>
           <a:prstGeom prst="rect">
             <a:avLst/>
@@ -4030,139 +5077,523 @@
             <a:spAutoFit/>
           </a:bodyPr>
           <a:lstStyle/>
-          <a:p>
-            <a:pPr>
+          <a:p/>
+        </p:txBody>
+      </p:sp>
+      <p:sp>
+        <p:nvSpPr>
+          <p:cNvPr id="6" name="TextBox 5"/>
+          <p:cNvSpPr txBox="1"/>
+          <p:nvPr/>
+        </p:nvSpPr>
+        <p:spPr>
+          <a:xfrm>
+            <a:off x="11155680" y="6355080"/>
+            <a:ext cx="822960" cy="365760"/>
+          </a:xfrm>
+          <a:prstGeom prst="rect">
+            <a:avLst/>
+          </a:prstGeom>
+          <a:noFill/>
+        </p:spPr>
+        <p:txBody>
+          <a:bodyPr wrap="square">
+            <a:spAutoFit/>
+          </a:bodyPr>
+          <a:lstStyle/>
+          <a:p>
+            <a:pPr algn="r">
               <a:spcAft>
-                <a:spcPts val="1000"/>
+                <a:spcPts val="800"/>
               </a:spcAft>
-              <a:defRPr sz="2200" b="0">
+              <a:defRPr sz="1400" b="0">
+                <a:solidFill>
+                  <a:srgbClr val="5A6478"/>
+                </a:solidFill>
+                <a:latin typeface="Calibri"/>
+              </a:defRPr>
+            </a:pPr>
+            <a:r>
+              <a:t>6</a:t>
+            </a:r>
+          </a:p>
+        </p:txBody>
+      </p:sp>
+      <p:sp>
+        <p:nvSpPr>
+          <p:cNvPr id="7" name="TextBox 6"/>
+          <p:cNvSpPr txBox="1"/>
+          <p:nvPr/>
+        </p:nvSpPr>
+        <p:spPr>
+          <a:xfrm>
+            <a:off x="548640" y="6355080"/>
+            <a:ext cx="7315200" cy="365760"/>
+          </a:xfrm>
+          <a:prstGeom prst="rect">
+            <a:avLst/>
+          </a:prstGeom>
+          <a:noFill/>
+        </p:spPr>
+        <p:txBody>
+          <a:bodyPr wrap="square">
+            <a:spAutoFit/>
+          </a:bodyPr>
+          <a:lstStyle/>
+          <a:p>
+            <a:pPr algn="l">
+              <a:spcAft>
+                <a:spcPts val="800"/>
+              </a:spcAft>
+              <a:defRPr sz="1200" b="0">
+                <a:solidFill>
+                  <a:srgbClr val="5A6478"/>
+                </a:solidFill>
+                <a:latin typeface="Calibri"/>
+              </a:defRPr>
+            </a:pPr>
+            <a:r>
+              <a:t>Воцуев Салах · гр. 2П1 · Компьютерные сети</a:t>
+            </a:r>
+          </a:p>
+        </p:txBody>
+      </p:sp>
+      <p:sp>
+        <p:nvSpPr>
+          <p:cNvPr id="8" name="Rounded Rectangle 7"/>
+          <p:cNvSpPr/>
+          <p:nvPr/>
+        </p:nvSpPr>
+        <p:spPr>
+          <a:xfrm>
+            <a:off x="640080" y="1645920"/>
+            <a:ext cx="5303520" cy="4389120"/>
+          </a:xfrm>
+          <a:prstGeom prst="roundRect">
+            <a:avLst>
+              <a:gd name="adj" fmla="val 5000"/>
+            </a:avLst>
+          </a:prstGeom>
+          <a:solidFill>
+            <a:srgbClr val="FFFFFF"/>
+          </a:solidFill>
+          <a:ln>
+            <a:solidFill>
+              <a:srgbClr val="DCE0E8"/>
+            </a:solidFill>
+          </a:ln>
+          <a:effectLst/>
+        </p:spPr>
+        <p:style>
+          <a:lnRef idx="1">
+            <a:schemeClr val="accent1"/>
+          </a:lnRef>
+          <a:fillRef idx="3">
+            <a:schemeClr val="accent1"/>
+          </a:fillRef>
+          <a:effectRef idx="2">
+            <a:schemeClr val="accent1"/>
+          </a:effectRef>
+          <a:fontRef idx="minor">
+            <a:schemeClr val="lt1"/>
+          </a:fontRef>
+        </p:style>
+        <p:txBody>
+          <a:bodyPr rtlCol="0" anchor="ctr"/>
+          <a:lstStyle/>
+          <a:p>
+            <a:pPr algn="ctr"/>
+          </a:p>
+        </p:txBody>
+      </p:sp>
+      <p:sp>
+        <p:nvSpPr>
+          <p:cNvPr id="9" name="Rounded Rectangle 8"/>
+          <p:cNvSpPr/>
+          <p:nvPr/>
+        </p:nvSpPr>
+        <p:spPr>
+          <a:xfrm>
+            <a:off x="640080" y="1645920"/>
+            <a:ext cx="5303520" cy="731520"/>
+          </a:xfrm>
+          <a:prstGeom prst="roundRect">
+            <a:avLst>
+              <a:gd name="adj" fmla="val 20000"/>
+            </a:avLst>
+          </a:prstGeom>
+          <a:solidFill>
+            <a:srgbClr val="228B54"/>
+          </a:solidFill>
+          <a:ln>
+            <a:noFill/>
+          </a:ln>
+          <a:effectLst/>
+        </p:spPr>
+        <p:style>
+          <a:lnRef idx="1">
+            <a:schemeClr val="accent1"/>
+          </a:lnRef>
+          <a:fillRef idx="3">
+            <a:schemeClr val="accent1"/>
+          </a:fillRef>
+          <a:effectRef idx="2">
+            <a:schemeClr val="accent1"/>
+          </a:effectRef>
+          <a:fontRef idx="minor">
+            <a:schemeClr val="lt1"/>
+          </a:fontRef>
+        </p:style>
+        <p:txBody>
+          <a:bodyPr rtlCol="0" anchor="ctr"/>
+          <a:lstStyle/>
+          <a:p>
+            <a:pPr algn="ctr"/>
+          </a:p>
+        </p:txBody>
+      </p:sp>
+      <p:sp>
+        <p:nvSpPr>
+          <p:cNvPr id="10" name="TextBox 9"/>
+          <p:cNvSpPr txBox="1"/>
+          <p:nvPr/>
+        </p:nvSpPr>
+        <p:spPr>
+          <a:xfrm>
+            <a:off x="914400" y="1719072"/>
+            <a:ext cx="4754880" cy="548640"/>
+          </a:xfrm>
+          <a:prstGeom prst="rect">
+            <a:avLst/>
+          </a:prstGeom>
+          <a:noFill/>
+        </p:spPr>
+        <p:txBody>
+          <a:bodyPr wrap="square">
+            <a:spAutoFit/>
+          </a:bodyPr>
+          <a:lstStyle/>
+          <a:p>
+            <a:pPr algn="l">
+              <a:spcAft>
+                <a:spcPts val="800"/>
+              </a:spcAft>
+              <a:defRPr sz="2400" b="1">
                 <a:solidFill>
                   <a:srgbClr val="FFFFFF"/>
                 </a:solidFill>
+                <a:latin typeface="Calibri"/>
               </a:defRPr>
             </a:pPr>
             <a:r>
-              <a:t>Достоинства:</a:t>
-            </a:r>
-          </a:p>
-          <a:p>
-            <a:pPr>
+              <a:t>Достоинства</a:t>
+            </a:r>
+          </a:p>
+        </p:txBody>
+      </p:sp>
+      <p:sp>
+        <p:nvSpPr>
+          <p:cNvPr id="11" name="TextBox 10"/>
+          <p:cNvSpPr txBox="1"/>
+          <p:nvPr/>
+        </p:nvSpPr>
+        <p:spPr>
+          <a:xfrm>
+            <a:off x="914400" y="2651760"/>
+            <a:ext cx="4754880" cy="3200400"/>
+          </a:xfrm>
+          <a:prstGeom prst="rect">
+            <a:avLst/>
+          </a:prstGeom>
+          <a:noFill/>
+        </p:spPr>
+        <p:txBody>
+          <a:bodyPr wrap="square">
+            <a:spAutoFit/>
+          </a:bodyPr>
+          <a:lstStyle/>
+          <a:p>
+            <a:pPr algn="l">
               <a:spcAft>
-                <a:spcPts val="1000"/>
+                <a:spcPts val="1400"/>
               </a:spcAft>
-              <a:defRPr sz="2200" b="0">
+              <a:defRPr sz="2100" b="0">
+                <a:solidFill>
+                  <a:srgbClr val="14213D"/>
+                </a:solidFill>
+                <a:latin typeface="Calibri"/>
+              </a:defRPr>
+            </a:pPr>
+            <a:r>
+              <a:t>+ Хорошая защита от помех</a:t>
+            </a:r>
+          </a:p>
+          <a:p>
+            <a:pPr algn="l">
+              <a:spcAft>
+                <a:spcPts val="1400"/>
+              </a:spcAft>
+              <a:defRPr sz="2100" b="0">
+                <a:solidFill>
+                  <a:srgbClr val="14213D"/>
+                </a:solidFill>
+                <a:latin typeface="Calibri"/>
+              </a:defRPr>
+            </a:pPr>
+            <a:r>
+              <a:t>+ Большая длина сегмента — 500 м</a:t>
+            </a:r>
+          </a:p>
+          <a:p>
+            <a:pPr algn="l">
+              <a:spcAft>
+                <a:spcPts val="1400"/>
+              </a:spcAft>
+              <a:defRPr sz="2100" b="0">
+                <a:solidFill>
+                  <a:srgbClr val="14213D"/>
+                </a:solidFill>
+                <a:latin typeface="Calibri"/>
+              </a:defRPr>
+            </a:pPr>
+            <a:r>
+              <a:t>+ Высокая механическая прочность</a:t>
+            </a:r>
+          </a:p>
+          <a:p>
+            <a:pPr algn="l">
+              <a:spcAft>
+                <a:spcPts val="1400"/>
+              </a:spcAft>
+              <a:defRPr sz="2100" b="0">
+                <a:solidFill>
+                  <a:srgbClr val="14213D"/>
+                </a:solidFill>
+                <a:latin typeface="Calibri"/>
+              </a:defRPr>
+            </a:pPr>
+            <a:r>
+              <a:t>+ Надёжность передачи сигнала</a:t>
+            </a:r>
+          </a:p>
+        </p:txBody>
+      </p:sp>
+      <p:sp>
+        <p:nvSpPr>
+          <p:cNvPr id="12" name="Rounded Rectangle 11"/>
+          <p:cNvSpPr/>
+          <p:nvPr/>
+        </p:nvSpPr>
+        <p:spPr>
+          <a:xfrm>
+            <a:off x="6263640" y="1645920"/>
+            <a:ext cx="5303520" cy="4389120"/>
+          </a:xfrm>
+          <a:prstGeom prst="roundRect">
+            <a:avLst>
+              <a:gd name="adj" fmla="val 5000"/>
+            </a:avLst>
+          </a:prstGeom>
+          <a:solidFill>
+            <a:srgbClr val="FFFFFF"/>
+          </a:solidFill>
+          <a:ln>
+            <a:solidFill>
+              <a:srgbClr val="DCE0E8"/>
+            </a:solidFill>
+          </a:ln>
+          <a:effectLst/>
+        </p:spPr>
+        <p:style>
+          <a:lnRef idx="1">
+            <a:schemeClr val="accent1"/>
+          </a:lnRef>
+          <a:fillRef idx="3">
+            <a:schemeClr val="accent1"/>
+          </a:fillRef>
+          <a:effectRef idx="2">
+            <a:schemeClr val="accent1"/>
+          </a:effectRef>
+          <a:fontRef idx="minor">
+            <a:schemeClr val="lt1"/>
+          </a:fontRef>
+        </p:style>
+        <p:txBody>
+          <a:bodyPr rtlCol="0" anchor="ctr"/>
+          <a:lstStyle/>
+          <a:p>
+            <a:pPr algn="ctr"/>
+          </a:p>
+        </p:txBody>
+      </p:sp>
+      <p:sp>
+        <p:nvSpPr>
+          <p:cNvPr id="13" name="Rounded Rectangle 12"/>
+          <p:cNvSpPr/>
+          <p:nvPr/>
+        </p:nvSpPr>
+        <p:spPr>
+          <a:xfrm>
+            <a:off x="6263640" y="1645920"/>
+            <a:ext cx="5303520" cy="731520"/>
+          </a:xfrm>
+          <a:prstGeom prst="roundRect">
+            <a:avLst>
+              <a:gd name="adj" fmla="val 20000"/>
+            </a:avLst>
+          </a:prstGeom>
+          <a:solidFill>
+            <a:srgbClr val="C83C3C"/>
+          </a:solidFill>
+          <a:ln>
+            <a:noFill/>
+          </a:ln>
+          <a:effectLst/>
+        </p:spPr>
+        <p:style>
+          <a:lnRef idx="1">
+            <a:schemeClr val="accent1"/>
+          </a:lnRef>
+          <a:fillRef idx="3">
+            <a:schemeClr val="accent1"/>
+          </a:fillRef>
+          <a:effectRef idx="2">
+            <a:schemeClr val="accent1"/>
+          </a:effectRef>
+          <a:fontRef idx="minor">
+            <a:schemeClr val="lt1"/>
+          </a:fontRef>
+        </p:style>
+        <p:txBody>
+          <a:bodyPr rtlCol="0" anchor="ctr"/>
+          <a:lstStyle/>
+          <a:p>
+            <a:pPr algn="ctr"/>
+          </a:p>
+        </p:txBody>
+      </p:sp>
+      <p:sp>
+        <p:nvSpPr>
+          <p:cNvPr id="14" name="TextBox 13"/>
+          <p:cNvSpPr txBox="1"/>
+          <p:nvPr/>
+        </p:nvSpPr>
+        <p:spPr>
+          <a:xfrm>
+            <a:off x="6537959" y="1719072"/>
+            <a:ext cx="4754880" cy="548640"/>
+          </a:xfrm>
+          <a:prstGeom prst="rect">
+            <a:avLst/>
+          </a:prstGeom>
+          <a:noFill/>
+        </p:spPr>
+        <p:txBody>
+          <a:bodyPr wrap="square">
+            <a:spAutoFit/>
+          </a:bodyPr>
+          <a:lstStyle/>
+          <a:p>
+            <a:pPr algn="l">
+              <a:spcAft>
+                <a:spcPts val="800"/>
+              </a:spcAft>
+              <a:defRPr sz="2400" b="1">
                 <a:solidFill>
                   <a:srgbClr val="FFFFFF"/>
                 </a:solidFill>
+                <a:latin typeface="Calibri"/>
               </a:defRPr>
             </a:pPr>
             <a:r>
-              <a:t>  + хорошая защита от помех</a:t>
-            </a:r>
-          </a:p>
-          <a:p>
-            <a:pPr>
+              <a:t>Недостатки</a:t>
+            </a:r>
+          </a:p>
+        </p:txBody>
+      </p:sp>
+      <p:sp>
+        <p:nvSpPr>
+          <p:cNvPr id="15" name="TextBox 14"/>
+          <p:cNvSpPr txBox="1"/>
+          <p:nvPr/>
+        </p:nvSpPr>
+        <p:spPr>
+          <a:xfrm>
+            <a:off x="6537959" y="2651760"/>
+            <a:ext cx="4754880" cy="3200400"/>
+          </a:xfrm>
+          <a:prstGeom prst="rect">
+            <a:avLst/>
+          </a:prstGeom>
+          <a:noFill/>
+        </p:spPr>
+        <p:txBody>
+          <a:bodyPr wrap="square">
+            <a:spAutoFit/>
+          </a:bodyPr>
+          <a:lstStyle/>
+          <a:p>
+            <a:pPr algn="l">
               <a:spcAft>
-                <a:spcPts val="1000"/>
+                <a:spcPts val="1400"/>
               </a:spcAft>
-              <a:defRPr sz="2200" b="0">
-                <a:solidFill>
-                  <a:srgbClr val="FFFFFF"/>
-                </a:solidFill>
+              <a:defRPr sz="2100" b="0">
+                <a:solidFill>
+                  <a:srgbClr val="14213D"/>
+                </a:solidFill>
+                <a:latin typeface="Calibri"/>
               </a:defRPr>
             </a:pPr>
             <a:r>
-              <a:t>  + большая длина сегмента (500 м)</a:t>
-            </a:r>
-          </a:p>
-          <a:p>
-            <a:pPr>
+              <a:t>− Толстый, жёсткий и тяжёлый</a:t>
+            </a:r>
+          </a:p>
+          <a:p>
+            <a:pPr algn="l">
               <a:spcAft>
-                <a:spcPts val="1000"/>
+                <a:spcPts val="1400"/>
               </a:spcAft>
-              <a:defRPr sz="2200" b="0">
-                <a:solidFill>
-                  <a:srgbClr val="FFFFFF"/>
-                </a:solidFill>
+              <a:defRPr sz="2100" b="0">
+                <a:solidFill>
+                  <a:srgbClr val="14213D"/>
+                </a:solidFill>
+                <a:latin typeface="Calibri"/>
               </a:defRPr>
             </a:pPr>
             <a:r>
-              <a:t>  + высокая механическая прочность</a:t>
-            </a:r>
-          </a:p>
-          <a:p>
-            <a:pPr>
+              <a:t>− Дорогой и сложный монтаж</a:t>
+            </a:r>
+          </a:p>
+          <a:p>
+            <a:pPr algn="l">
               <a:spcAft>
-                <a:spcPts val="1000"/>
+                <a:spcPts val="1400"/>
               </a:spcAft>
-              <a:defRPr sz="2200" b="0">
-                <a:solidFill>
-                  <a:srgbClr val="FFFFFF"/>
-                </a:solidFill>
+              <a:defRPr sz="2100" b="0">
+                <a:solidFill>
+                  <a:srgbClr val="14213D"/>
+                </a:solidFill>
+                <a:latin typeface="Calibri"/>
               </a:defRPr>
             </a:pPr>
             <a:r>
-              <a:t>Недостатки:</a:t>
-            </a:r>
-          </a:p>
-          <a:p>
-            <a:pPr>
+              <a:t>− Низкая скорость — 10 Мбит/с</a:t>
+            </a:r>
+          </a:p>
+          <a:p>
+            <a:pPr algn="l">
               <a:spcAft>
-                <a:spcPts val="1000"/>
+                <a:spcPts val="1400"/>
               </a:spcAft>
-              <a:defRPr sz="2200" b="0">
-                <a:solidFill>
-                  <a:srgbClr val="FFFFFF"/>
-                </a:solidFill>
+              <a:defRPr sz="2100" b="0">
+                <a:solidFill>
+                  <a:srgbClr val="14213D"/>
+                </a:solidFill>
+                <a:latin typeface="Calibri"/>
               </a:defRPr>
             </a:pPr>
             <a:r>
-              <a:t>  − толстый, жёсткий и тяжёлый</a:t>
-            </a:r>
-          </a:p>
-          <a:p>
-            <a:pPr>
-              <a:spcAft>
-                <a:spcPts val="1000"/>
-              </a:spcAft>
-              <a:defRPr sz="2200" b="0">
-                <a:solidFill>
-                  <a:srgbClr val="FFFFFF"/>
-                </a:solidFill>
-              </a:defRPr>
-            </a:pPr>
-            <a:r>
-              <a:t>  − дорогой и сложный монтаж</a:t>
-            </a:r>
-          </a:p>
-          <a:p>
-            <a:pPr>
-              <a:spcAft>
-                <a:spcPts val="1000"/>
-              </a:spcAft>
-              <a:defRPr sz="2200" b="0">
-                <a:solidFill>
-                  <a:srgbClr val="FFFFFF"/>
-                </a:solidFill>
-              </a:defRPr>
-            </a:pPr>
-            <a:r>
-              <a:t>  − низкая скорость (10 Мбит/с)</a:t>
-            </a:r>
-          </a:p>
-          <a:p>
-            <a:pPr>
-              <a:spcAft>
-                <a:spcPts val="1000"/>
-              </a:spcAft>
-              <a:defRPr sz="2200" b="0">
-                <a:solidFill>
-                  <a:srgbClr val="FFFFFF"/>
-                </a:solidFill>
-              </a:defRPr>
-            </a:pPr>
-            <a:r>
-              <a:t>  − обрыв кабеля останавливает всю сеть</a:t>
+              <a:t>− Обрыв кабеля останавливает всю сеть</a:t>
             </a:r>
           </a:p>
         </p:txBody>
@@ -4181,7 +5612,7 @@
     <p:bg>
       <p:bgPr>
         <a:solidFill>
-          <a:srgbClr val="141E30"/>
+          <a:srgbClr val="F8F9FC"/>
         </a:solidFill>
         <a:effectLst/>
       </p:bgPr>
@@ -4195,14 +5626,102 @@
       <p:grpSpPr/>
       <p:sp>
         <p:nvSpPr>
-          <p:cNvPr id="2" name="TextBox 1"/>
+          <p:cNvPr id="2" name="Rectangle 1"/>
+          <p:cNvSpPr/>
+          <p:nvPr/>
+        </p:nvSpPr>
+        <p:spPr>
+          <a:xfrm>
+            <a:off x="0" y="0"/>
+            <a:ext cx="12191695" cy="1143000"/>
+          </a:xfrm>
+          <a:prstGeom prst="rect">
+            <a:avLst/>
+          </a:prstGeom>
+          <a:solidFill>
+            <a:srgbClr val="14213D"/>
+          </a:solidFill>
+          <a:ln>
+            <a:noFill/>
+          </a:ln>
+          <a:effectLst/>
+        </p:spPr>
+        <p:style>
+          <a:lnRef idx="1">
+            <a:schemeClr val="accent1"/>
+          </a:lnRef>
+          <a:fillRef idx="3">
+            <a:schemeClr val="accent1"/>
+          </a:fillRef>
+          <a:effectRef idx="2">
+            <a:schemeClr val="accent1"/>
+          </a:effectRef>
+          <a:fontRef idx="minor">
+            <a:schemeClr val="lt1"/>
+          </a:fontRef>
+        </p:style>
+        <p:txBody>
+          <a:bodyPr rtlCol="0" anchor="ctr"/>
+          <a:lstStyle/>
+          <a:p>
+            <a:pPr algn="ctr"/>
+          </a:p>
+        </p:txBody>
+      </p:sp>
+      <p:sp>
+        <p:nvSpPr>
+          <p:cNvPr id="3" name="Rectangle 2"/>
+          <p:cNvSpPr/>
+          <p:nvPr/>
+        </p:nvSpPr>
+        <p:spPr>
+          <a:xfrm>
+            <a:off x="0" y="1143000"/>
+            <a:ext cx="12191695" cy="73152"/>
+          </a:xfrm>
+          <a:prstGeom prst="rect">
+            <a:avLst/>
+          </a:prstGeom>
+          <a:solidFill>
+            <a:srgbClr val="E8BC1C"/>
+          </a:solidFill>
+          <a:ln>
+            <a:noFill/>
+          </a:ln>
+          <a:effectLst/>
+        </p:spPr>
+        <p:style>
+          <a:lnRef idx="1">
+            <a:schemeClr val="accent1"/>
+          </a:lnRef>
+          <a:fillRef idx="3">
+            <a:schemeClr val="accent1"/>
+          </a:fillRef>
+          <a:effectRef idx="2">
+            <a:schemeClr val="accent1"/>
+          </a:effectRef>
+          <a:fontRef idx="minor">
+            <a:schemeClr val="lt1"/>
+          </a:fontRef>
+        </p:style>
+        <p:txBody>
+          <a:bodyPr rtlCol="0" anchor="ctr"/>
+          <a:lstStyle/>
+          <a:p>
+            <a:pPr algn="ctr"/>
+          </a:p>
+        </p:txBody>
+      </p:sp>
+      <p:sp>
+        <p:nvSpPr>
+          <p:cNvPr id="4" name="TextBox 3"/>
           <p:cNvSpPr txBox="1"/>
           <p:nvPr/>
         </p:nvSpPr>
         <p:spPr>
           <a:xfrm>
-            <a:off x="548640" y="365760"/>
-            <a:ext cx="10972800" cy="914400"/>
+            <a:off x="548640" y="228600"/>
+            <a:ext cx="10972800" cy="822960"/>
           </a:xfrm>
           <a:prstGeom prst="rect">
             <a:avLst/>
@@ -4215,14 +5734,15 @@
           </a:bodyPr>
           <a:lstStyle/>
           <a:p>
-            <a:pPr>
+            <a:pPr algn="l">
               <a:spcAft>
-                <a:spcPts val="1000"/>
+                <a:spcPts val="800"/>
               </a:spcAft>
-              <a:defRPr sz="3600" b="1">
-                <a:solidFill>
-                  <a:srgbClr val="F2C200"/>
-                </a:solidFill>
+              <a:defRPr sz="3400" b="1">
+                <a:solidFill>
+                  <a:srgbClr val="FFFFFF"/>
+                </a:solidFill>
+                <a:latin typeface="Calibri"/>
               </a:defRPr>
             </a:pPr>
             <a:r>
@@ -4233,14 +5753,14 @@
       </p:sp>
       <p:sp>
         <p:nvSpPr>
-          <p:cNvPr id="3" name="TextBox 2"/>
+          <p:cNvPr id="5" name="TextBox 4"/>
           <p:cNvSpPr txBox="1"/>
           <p:nvPr/>
         </p:nvSpPr>
         <p:spPr>
           <a:xfrm>
-            <a:off x="548640" y="1463040"/>
-            <a:ext cx="10972800" cy="5029200"/>
+            <a:off x="640080" y="1645920"/>
+            <a:ext cx="7223759" cy="4846320"/>
           </a:xfrm>
           <a:prstGeom prst="rect">
             <a:avLst/>
@@ -4253,14 +5773,15 @@
           </a:bodyPr>
           <a:lstStyle/>
           <a:p>
-            <a:pPr>
+            <a:pPr algn="l">
               <a:spcAft>
-                <a:spcPts val="1000"/>
+                <a:spcPts val="1200"/>
               </a:spcAft>
-              <a:defRPr sz="2200" b="0">
-                <a:solidFill>
-                  <a:srgbClr val="FFFFFF"/>
-                </a:solidFill>
+              <a:defRPr sz="2100" b="0">
+                <a:solidFill>
+                  <a:srgbClr val="14213D"/>
+                </a:solidFill>
+                <a:latin typeface="Calibri"/>
               </a:defRPr>
             </a:pPr>
             <a:r>
@@ -4268,60 +5789,166 @@
             </a:r>
           </a:p>
           <a:p>
-            <a:pPr>
+            <a:pPr algn="l">
               <a:spcAft>
-                <a:spcPts val="1000"/>
+                <a:spcPts val="1200"/>
               </a:spcAft>
-              <a:defRPr sz="2200" b="0">
-                <a:solidFill>
-                  <a:srgbClr val="FFFFFF"/>
-                </a:solidFill>
+              <a:defRPr sz="2100" b="0">
+                <a:solidFill>
+                  <a:srgbClr val="14213D"/>
+                </a:solidFill>
+                <a:latin typeface="Calibri"/>
               </a:defRPr>
             </a:pPr>
             <a:r>
-              <a:t>• Он обеспечивал надёжную передачу данных на большие расстояния.</a:t>
-            </a:r>
-          </a:p>
-          <a:p>
-            <a:pPr>
+              <a:t>• Он надёжно передавал данные на расстояние до 500 м и хорошо защищал сигнал от помех.</a:t>
+            </a:r>
+          </a:p>
+          <a:p>
+            <a:pPr algn="l">
               <a:spcAft>
-                <a:spcPts val="1000"/>
+                <a:spcPts val="1200"/>
               </a:spcAft>
-              <a:defRPr sz="2200" b="0">
-                <a:solidFill>
-                  <a:srgbClr val="FFFFFF"/>
-                </a:solidFill>
+              <a:defRPr sz="2100" b="0">
+                <a:solidFill>
+                  <a:srgbClr val="14213D"/>
+                </a:solidFill>
+                <a:latin typeface="Calibri"/>
               </a:defRPr>
             </a:pPr>
             <a:r>
-              <a:t>• Сегодня почти не применяется, но важен для понимания истории и устройства компьютерных сетей.</a:t>
-            </a:r>
-          </a:p>
-          <a:p>
-            <a:pPr>
+              <a:t>• Сейчас почти не применяется, но важен для понимания истории и устройства компьютерных сетей.</a:t>
+            </a:r>
+          </a:p>
+          <a:p>
+            <a:pPr algn="l">
               <a:spcAft>
-                <a:spcPts val="1000"/>
+                <a:spcPts val="1200"/>
               </a:spcAft>
-              <a:defRPr sz="2200" b="0">
-                <a:solidFill>
-                  <a:srgbClr val="FFFFFF"/>
-                </a:solidFill>
+              <a:defRPr sz="2100" b="0">
+                <a:solidFill>
+                  <a:srgbClr val="14213D"/>
+                </a:solidFill>
+                <a:latin typeface="Calibri"/>
               </a:defRPr>
             </a:pPr>
           </a:p>
           <a:p>
-            <a:pPr>
+            <a:pPr algn="l">
               <a:spcAft>
-                <a:spcPts val="1000"/>
+                <a:spcPts val="1200"/>
               </a:spcAft>
-              <a:defRPr sz="2200" b="0">
-                <a:solidFill>
-                  <a:srgbClr val="FFFFFF"/>
-                </a:solidFill>
+              <a:defRPr sz="2100" b="1">
+                <a:solidFill>
+                  <a:srgbClr val="14213D"/>
+                </a:solidFill>
+                <a:latin typeface="Calibri"/>
               </a:defRPr>
             </a:pPr>
             <a:r>
               <a:t>Спасибо за внимание!</a:t>
+            </a:r>
+          </a:p>
+        </p:txBody>
+      </p:sp>
+      <p:pic>
+        <p:nvPicPr>
+          <p:cNvPr id="6" name="Picture 5" descr="img_section.png"/>
+          <p:cNvPicPr>
+            <a:picLocks noChangeAspect="1"/>
+          </p:cNvPicPr>
+          <p:nvPr/>
+        </p:nvPicPr>
+        <p:blipFill>
+          <a:blip r:embed="rId2"/>
+          <a:stretch>
+            <a:fillRect/>
+          </a:stretch>
+        </p:blipFill>
+        <p:spPr>
+          <a:xfrm>
+            <a:off x="8442655" y="1828800"/>
+            <a:ext cx="3291840" cy="3291840"/>
+          </a:xfrm>
+          <a:prstGeom prst="rect">
+            <a:avLst/>
+          </a:prstGeom>
+        </p:spPr>
+      </p:pic>
+      <p:sp>
+        <p:nvSpPr>
+          <p:cNvPr id="7" name="TextBox 6"/>
+          <p:cNvSpPr txBox="1"/>
+          <p:nvPr/>
+        </p:nvSpPr>
+        <p:spPr>
+          <a:xfrm>
+            <a:off x="11155680" y="6355080"/>
+            <a:ext cx="822960" cy="365760"/>
+          </a:xfrm>
+          <a:prstGeom prst="rect">
+            <a:avLst/>
+          </a:prstGeom>
+          <a:noFill/>
+        </p:spPr>
+        <p:txBody>
+          <a:bodyPr wrap="square">
+            <a:spAutoFit/>
+          </a:bodyPr>
+          <a:lstStyle/>
+          <a:p>
+            <a:pPr algn="r">
+              <a:spcAft>
+                <a:spcPts val="800"/>
+              </a:spcAft>
+              <a:defRPr sz="1400" b="0">
+                <a:solidFill>
+                  <a:srgbClr val="5A6478"/>
+                </a:solidFill>
+                <a:latin typeface="Calibri"/>
+              </a:defRPr>
+            </a:pPr>
+            <a:r>
+              <a:t>7</a:t>
+            </a:r>
+          </a:p>
+        </p:txBody>
+      </p:sp>
+      <p:sp>
+        <p:nvSpPr>
+          <p:cNvPr id="8" name="TextBox 7"/>
+          <p:cNvSpPr txBox="1"/>
+          <p:nvPr/>
+        </p:nvSpPr>
+        <p:spPr>
+          <a:xfrm>
+            <a:off x="548640" y="6355080"/>
+            <a:ext cx="7315200" cy="365760"/>
+          </a:xfrm>
+          <a:prstGeom prst="rect">
+            <a:avLst/>
+          </a:prstGeom>
+          <a:noFill/>
+        </p:spPr>
+        <p:txBody>
+          <a:bodyPr wrap="square">
+            <a:spAutoFit/>
+          </a:bodyPr>
+          <a:lstStyle/>
+          <a:p>
+            <a:pPr algn="l">
+              <a:spcAft>
+                <a:spcPts val="800"/>
+              </a:spcAft>
+              <a:defRPr sz="1200" b="0">
+                <a:solidFill>
+                  <a:srgbClr val="5A6478"/>
+                </a:solidFill>
+                <a:latin typeface="Calibri"/>
+              </a:defRPr>
+            </a:pPr>
+            <a:r>
+              <a:t>Воцуев Салах · гр. 2П1 · Компьютерные сети</a:t>
             </a:r>
           </a:p>
         </p:txBody>

</xml_diff>

<commit_message>
Remove discipline text from title slide
Co-Authored-By: Claude Haiku 4.5 <noreply@anthropic.com>
Claude-Session: https://claude.ai/code/session_014t6tUZzpxufuWreCCCTSrh
</commit_message>
<xml_diff>
--- a/presentation/Толстый_коаксиальный_кабель.pptx
+++ b/presentation/Толстый_коаксиальный_кабель.pptx
@@ -3199,45 +3199,6 @@
         <p:spPr>
           <a:xfrm>
             <a:off x="731520" y="457200"/>
-            <a:ext cx="10698480" cy="457200"/>
-          </a:xfrm>
-          <a:prstGeom prst="rect">
-            <a:avLst/>
-          </a:prstGeom>
-          <a:noFill/>
-        </p:spPr>
-        <p:txBody>
-          <a:bodyPr wrap="square">
-            <a:spAutoFit/>
-          </a:bodyPr>
-          <a:lstStyle/>
-          <a:p>
-            <a:pPr algn="ctr">
-              <a:spcAft>
-                <a:spcPts val="800"/>
-              </a:spcAft>
-              <a:defRPr sz="2000" b="1">
-                <a:solidFill>
-                  <a:srgbClr val="E8BC1C"/>
-                </a:solidFill>
-                <a:latin typeface="Calibri"/>
-              </a:defRPr>
-            </a:pPr>
-            <a:r>
-              <a:t>Дисциплина: Компьютерные сети</a:t>
-            </a:r>
-          </a:p>
-        </p:txBody>
-      </p:sp>
-      <p:sp>
-        <p:nvSpPr>
-          <p:cNvPr id="5" name="TextBox 4"/>
-          <p:cNvSpPr txBox="1"/>
-          <p:nvPr/>
-        </p:nvSpPr>
-        <p:spPr>
-          <a:xfrm>
-            <a:off x="731520" y="1005840"/>
             <a:ext cx="10698480" cy="1097280"/>
           </a:xfrm>
           <a:prstGeom prst="rect">
@@ -3270,7 +3231,7 @@
       </p:sp>
       <p:sp>
         <p:nvSpPr>
-          <p:cNvPr id="6" name="TextBox 5"/>
+          <p:cNvPr id="5" name="TextBox 4"/>
           <p:cNvSpPr txBox="1"/>
           <p:nvPr/>
         </p:nvSpPr>
@@ -3309,7 +3270,7 @@
       </p:sp>
       <p:pic>
         <p:nvPicPr>
-          <p:cNvPr id="7" name="Picture 6" descr="img_cable_t.png"/>
+          <p:cNvPr id="6" name="Picture 5" descr="img_cable_t.png"/>
           <p:cNvPicPr>
             <a:picLocks noChangeAspect="1"/>
           </p:cNvPicPr>
@@ -3333,7 +3294,7 @@
       </p:pic>
       <p:sp>
         <p:nvSpPr>
-          <p:cNvPr id="8" name="Rounded Rectangle 7"/>
+          <p:cNvPr id="7" name="Rounded Rectangle 6"/>
           <p:cNvSpPr/>
           <p:nvPr/>
         </p:nvSpPr>
@@ -3379,7 +3340,7 @@
       </p:sp>
       <p:sp>
         <p:nvSpPr>
-          <p:cNvPr id="9" name="TextBox 8"/>
+          <p:cNvPr id="8" name="TextBox 7"/>
           <p:cNvSpPr txBox="1"/>
           <p:nvPr/>
         </p:nvSpPr>

</xml_diff>

<commit_message>
Remove author info from bottom of slides (keep only slide numbers)
Co-Authored-By: Claude Haiku 4.5 <noreply@anthropic.com>
Claude-Session: https://claude.ai/code/session_014t6tUZzpxufuWreCCCTSrh
</commit_message>
<xml_diff>
--- a/presentation/Толстый_коаксиальный_кабель.pptx
+++ b/presentation/Толстый_коаксиальный_кабель.pptx
@@ -3728,45 +3728,6 @@
           </a:p>
         </p:txBody>
       </p:sp>
-      <p:sp>
-        <p:nvSpPr>
-          <p:cNvPr id="8" name="TextBox 7"/>
-          <p:cNvSpPr txBox="1"/>
-          <p:nvPr/>
-        </p:nvSpPr>
-        <p:spPr>
-          <a:xfrm>
-            <a:off x="548640" y="6355080"/>
-            <a:ext cx="7315200" cy="365760"/>
-          </a:xfrm>
-          <a:prstGeom prst="rect">
-            <a:avLst/>
-          </a:prstGeom>
-          <a:noFill/>
-        </p:spPr>
-        <p:txBody>
-          <a:bodyPr wrap="square">
-            <a:spAutoFit/>
-          </a:bodyPr>
-          <a:lstStyle/>
-          <a:p>
-            <a:pPr algn="l">
-              <a:spcAft>
-                <a:spcPts val="800"/>
-              </a:spcAft>
-              <a:defRPr sz="1200" b="0">
-                <a:solidFill>
-                  <a:srgbClr val="5A6478"/>
-                </a:solidFill>
-                <a:latin typeface="Calibri"/>
-              </a:defRPr>
-            </a:pPr>
-            <a:r>
-              <a:t>Воцуев Салах · гр. 2П1 · Компьютерные сети</a:t>
-            </a:r>
-          </a:p>
-        </p:txBody>
-      </p:sp>
     </p:spTree>
   </p:cSld>
   <p:clrMapOvr>
@@ -4070,45 +4031,6 @@
           </a:p>
         </p:txBody>
       </p:sp>
-      <p:sp>
-        <p:nvSpPr>
-          <p:cNvPr id="8" name="TextBox 7"/>
-          <p:cNvSpPr txBox="1"/>
-          <p:nvPr/>
-        </p:nvSpPr>
-        <p:spPr>
-          <a:xfrm>
-            <a:off x="548640" y="6355080"/>
-            <a:ext cx="7315200" cy="365760"/>
-          </a:xfrm>
-          <a:prstGeom prst="rect">
-            <a:avLst/>
-          </a:prstGeom>
-          <a:noFill/>
-        </p:spPr>
-        <p:txBody>
-          <a:bodyPr wrap="square">
-            <a:spAutoFit/>
-          </a:bodyPr>
-          <a:lstStyle/>
-          <a:p>
-            <a:pPr algn="l">
-              <a:spcAft>
-                <a:spcPts val="800"/>
-              </a:spcAft>
-              <a:defRPr sz="1200" b="0">
-                <a:solidFill>
-                  <a:srgbClr val="5A6478"/>
-                </a:solidFill>
-                <a:latin typeface="Calibri"/>
-              </a:defRPr>
-            </a:pPr>
-            <a:r>
-              <a:t>Воцуев Салах · гр. 2П1 · Компьютерные сети</a:t>
-            </a:r>
-          </a:p>
-        </p:txBody>
-      </p:sp>
     </p:spTree>
   </p:cSld>
   <p:clrMapOvr>
@@ -4444,45 +4366,6 @@
           </a:p>
         </p:txBody>
       </p:sp>
-      <p:sp>
-        <p:nvSpPr>
-          <p:cNvPr id="8" name="TextBox 7"/>
-          <p:cNvSpPr txBox="1"/>
-          <p:nvPr/>
-        </p:nvSpPr>
-        <p:spPr>
-          <a:xfrm>
-            <a:off x="548640" y="6355080"/>
-            <a:ext cx="7315200" cy="365760"/>
-          </a:xfrm>
-          <a:prstGeom prst="rect">
-            <a:avLst/>
-          </a:prstGeom>
-          <a:noFill/>
-        </p:spPr>
-        <p:txBody>
-          <a:bodyPr wrap="square">
-            <a:spAutoFit/>
-          </a:bodyPr>
-          <a:lstStyle/>
-          <a:p>
-            <a:pPr algn="l">
-              <a:spcAft>
-                <a:spcPts val="800"/>
-              </a:spcAft>
-              <a:defRPr sz="1200" b="0">
-                <a:solidFill>
-                  <a:srgbClr val="5A6478"/>
-                </a:solidFill>
-                <a:latin typeface="Calibri"/>
-              </a:defRPr>
-            </a:pPr>
-            <a:r>
-              <a:t>Воцуев Салах · гр. 2П1 · Компьютерные сети</a:t>
-            </a:r>
-          </a:p>
-        </p:txBody>
-      </p:sp>
     </p:spTree>
   </p:cSld>
   <p:clrMapOvr>
@@ -4786,45 +4669,6 @@
           </a:p>
         </p:txBody>
       </p:sp>
-      <p:sp>
-        <p:nvSpPr>
-          <p:cNvPr id="8" name="TextBox 7"/>
-          <p:cNvSpPr txBox="1"/>
-          <p:nvPr/>
-        </p:nvSpPr>
-        <p:spPr>
-          <a:xfrm>
-            <a:off x="548640" y="6355080"/>
-            <a:ext cx="7315200" cy="365760"/>
-          </a:xfrm>
-          <a:prstGeom prst="rect">
-            <a:avLst/>
-          </a:prstGeom>
-          <a:noFill/>
-        </p:spPr>
-        <p:txBody>
-          <a:bodyPr wrap="square">
-            <a:spAutoFit/>
-          </a:bodyPr>
-          <a:lstStyle/>
-          <a:p>
-            <a:pPr algn="l">
-              <a:spcAft>
-                <a:spcPts val="800"/>
-              </a:spcAft>
-              <a:defRPr sz="1200" b="0">
-                <a:solidFill>
-                  <a:srgbClr val="5A6478"/>
-                </a:solidFill>
-                <a:latin typeface="Calibri"/>
-              </a:defRPr>
-            </a:pPr>
-            <a:r>
-              <a:t>Воцуев Салах · гр. 2П1 · Компьютерные сети</a:t>
-            </a:r>
-          </a:p>
-        </p:txBody>
-      </p:sp>
     </p:spTree>
   </p:cSld>
   <p:clrMapOvr>
@@ -5043,46 +4887,7 @@
       </p:sp>
       <p:sp>
         <p:nvSpPr>
-          <p:cNvPr id="7" name="TextBox 6"/>
-          <p:cNvSpPr txBox="1"/>
-          <p:nvPr/>
-        </p:nvSpPr>
-        <p:spPr>
-          <a:xfrm>
-            <a:off x="548640" y="6355080"/>
-            <a:ext cx="7315200" cy="365760"/>
-          </a:xfrm>
-          <a:prstGeom prst="rect">
-            <a:avLst/>
-          </a:prstGeom>
-          <a:noFill/>
-        </p:spPr>
-        <p:txBody>
-          <a:bodyPr wrap="square">
-            <a:spAutoFit/>
-          </a:bodyPr>
-          <a:lstStyle/>
-          <a:p>
-            <a:pPr algn="l">
-              <a:spcAft>
-                <a:spcPts val="800"/>
-              </a:spcAft>
-              <a:defRPr sz="1200" b="0">
-                <a:solidFill>
-                  <a:srgbClr val="5A6478"/>
-                </a:solidFill>
-                <a:latin typeface="Calibri"/>
-              </a:defRPr>
-            </a:pPr>
-            <a:r>
-              <a:t>Воцуев Салах · гр. 2П1 · Компьютерные сети</a:t>
-            </a:r>
-          </a:p>
-        </p:txBody>
-      </p:sp>
-      <p:sp>
-        <p:nvSpPr>
-          <p:cNvPr id="8" name="Rounded Rectangle 7"/>
+          <p:cNvPr id="7" name="Rounded Rectangle 6"/>
           <p:cNvSpPr/>
           <p:nvPr/>
         </p:nvSpPr>
@@ -5130,7 +4935,7 @@
       </p:sp>
       <p:sp>
         <p:nvSpPr>
-          <p:cNvPr id="9" name="Rounded Rectangle 8"/>
+          <p:cNvPr id="8" name="Rounded Rectangle 7"/>
           <p:cNvSpPr/>
           <p:nvPr/>
         </p:nvSpPr>
@@ -5176,7 +4981,7 @@
       </p:sp>
       <p:sp>
         <p:nvSpPr>
-          <p:cNvPr id="10" name="TextBox 9"/>
+          <p:cNvPr id="9" name="TextBox 8"/>
           <p:cNvSpPr txBox="1"/>
           <p:nvPr/>
         </p:nvSpPr>
@@ -5215,7 +5020,7 @@
       </p:sp>
       <p:sp>
         <p:nvSpPr>
-          <p:cNvPr id="11" name="TextBox 10"/>
+          <p:cNvPr id="10" name="TextBox 9"/>
           <p:cNvSpPr txBox="1"/>
           <p:nvPr/>
         </p:nvSpPr>
@@ -5302,7 +5107,7 @@
       </p:sp>
       <p:sp>
         <p:nvSpPr>
-          <p:cNvPr id="12" name="Rounded Rectangle 11"/>
+          <p:cNvPr id="11" name="Rounded Rectangle 10"/>
           <p:cNvSpPr/>
           <p:nvPr/>
         </p:nvSpPr>
@@ -5350,7 +5155,7 @@
       </p:sp>
       <p:sp>
         <p:nvSpPr>
-          <p:cNvPr id="13" name="Rounded Rectangle 12"/>
+          <p:cNvPr id="12" name="Rounded Rectangle 11"/>
           <p:cNvSpPr/>
           <p:nvPr/>
         </p:nvSpPr>
@@ -5396,7 +5201,7 @@
       </p:sp>
       <p:sp>
         <p:nvSpPr>
-          <p:cNvPr id="14" name="TextBox 13"/>
+          <p:cNvPr id="13" name="TextBox 12"/>
           <p:cNvSpPr txBox="1"/>
           <p:nvPr/>
         </p:nvSpPr>
@@ -5435,7 +5240,7 @@
       </p:sp>
       <p:sp>
         <p:nvSpPr>
-          <p:cNvPr id="15" name="TextBox 14"/>
+          <p:cNvPr id="14" name="TextBox 13"/>
           <p:cNvSpPr txBox="1"/>
           <p:nvPr/>
         </p:nvSpPr>
@@ -5832,45 +5637,6 @@
             </a:pPr>
             <a:r>
               <a:t>7</a:t>
-            </a:r>
-          </a:p>
-        </p:txBody>
-      </p:sp>
-      <p:sp>
-        <p:nvSpPr>
-          <p:cNvPr id="8" name="TextBox 7"/>
-          <p:cNvSpPr txBox="1"/>
-          <p:nvPr/>
-        </p:nvSpPr>
-        <p:spPr>
-          <a:xfrm>
-            <a:off x="548640" y="6355080"/>
-            <a:ext cx="7315200" cy="365760"/>
-          </a:xfrm>
-          <a:prstGeom prst="rect">
-            <a:avLst/>
-          </a:prstGeom>
-          <a:noFill/>
-        </p:spPr>
-        <p:txBody>
-          <a:bodyPr wrap="square">
-            <a:spAutoFit/>
-          </a:bodyPr>
-          <a:lstStyle/>
-          <a:p>
-            <a:pPr algn="l">
-              <a:spcAft>
-                <a:spcPts val="800"/>
-              </a:spcAft>
-              <a:defRPr sz="1200" b="0">
-                <a:solidFill>
-                  <a:srgbClr val="5A6478"/>
-                </a:solidFill>
-                <a:latin typeface="Calibri"/>
-              </a:defRPr>
-            </a:pPr>
-            <a:r>
-              <a:t>Воцуев Салах · гр. 2П1 · Компьютерные сети</a:t>
             </a:r>
           </a:p>
         </p:txBody>

</xml_diff>